<commit_message>
chore(concurso): align sustentation deck with 2026 guidelines
Restructure the pitch to eight official slides (team ID, repo, demo, impact) and regenerate PPTX/PDF for the 10-minute presentation block.

Co-authored-by: Cursor <cursoragent@cursor.com>
</commit_message>
<xml_diff>
--- a/RECURSOS/Presentacion.pptx
+++ b/RECURSOS/Presentacion.pptx
@@ -3132,20 +3132,40 @@
           <a:lstStyle/>
           <a:p>
             <a:r>
-              <a:rPr sz="2000"/>
-              <a:t>Inteligencia epidemiológica territorial</a:t>
-            </a:r>
-          </a:p>
-          <a:p>
-            <a:r>
-              <a:rPr sz="2000"/>
-              <a:t>Concurso Datos Abiertos Colombia 2026</a:t>
-            </a:r>
-          </a:p>
-          <a:p>
-            <a:r>
-              <a:rPr sz="2000"/>
-              <a:t>Equipo ID 200 · Salud y Bienestar</a:t>
+              <a:rPr sz="1800"/>
+              <a:t>Concurso Datos al Ecosistema 2026 · IA para Colombia</a:t>
+            </a:r>
+          </a:p>
+          <a:p/>
+          <a:p>
+            <a:r>
+              <a:rPr sz="1800"/>
+              <a:t>Equipo ID 200 · Nivel Intermedio (IA)</a:t>
+            </a:r>
+          </a:p>
+          <a:p>
+            <a:r>
+              <a:rPr sz="1800"/>
+              <a:t>Reto: Salud y Bienestar — brotes transmisibles</a:t>
+            </a:r>
+          </a:p>
+          <a:p/>
+          <a:p>
+            <a:r>
+              <a:rPr sz="1800"/>
+              <a:t>Integrantes:</a:t>
+            </a:r>
+          </a:p>
+          <a:p>
+            <a:r>
+              <a:rPr sz="1800"/>
+              <a:t>• Líder — luisrapalino88@gmail.com</a:t>
+            </a:r>
+          </a:p>
+          <a:p>
+            <a:r>
+              <a:rPr sz="1800"/>
+              <a:t>• Participante 2 — Rapalinorokate@gmail.com</a:t>
             </a:r>
           </a:p>
         </p:txBody>
@@ -3184,7 +3204,7 @@
           <a:lstStyle/>
           <a:p>
             <a:r>
-              <a:t>Problema</a:t>
+              <a:t>Problema y objetivo</a:t>
             </a:r>
           </a:p>
         </p:txBody>
@@ -3205,39 +3225,27 @@
           <a:lstStyle/>
           <a:p>
             <a:r>
-              <a:rPr sz="2000"/>
-              <a:t>Predecir brotes de enfermedades transmisibles integrando:</a:t>
-            </a:r>
-          </a:p>
-          <a:p>
-            <a:r>
-              <a:rPr sz="2000"/>
-              <a:t>• Morbilidad (SIVIGILA)</a:t>
-            </a:r>
-          </a:p>
-          <a:p>
-            <a:r>
-              <a:rPr sz="2000"/>
-              <a:t>• Vacunación</a:t>
-            </a:r>
-          </a:p>
-          <a:p>
-            <a:r>
-              <a:rPr sz="2000"/>
-              <a:t>• Calidad del aire (PM2.5)</a:t>
-            </a:r>
-          </a:p>
-          <a:p>
-            <a:r>
-              <a:rPr sz="2000"/>
-              <a:t>• Acceso a servicios de salud</a:t>
+              <a:rPr sz="1800"/>
+              <a:t>Problema:</a:t>
+            </a:r>
+          </a:p>
+          <a:p>
+            <a:r>
+              <a:rPr sz="1800"/>
+              <a:t>Los brotes de enfermedades transmisibles requieren detección temprana, pero la información está dispersa en fuentes abiertas.</a:t>
             </a:r>
           </a:p>
           <a:p/>
           <a:p>
             <a:r>
-              <a:rPr sz="2000"/>
-              <a:t>Objetivo: apoyar prevención y respuesta temprana con revisión humana.</a:t>
+              <a:rPr sz="1800"/>
+              <a:t>Objetivo:</a:t>
+            </a:r>
+          </a:p>
+          <a:p>
+            <a:r>
+              <a:rPr sz="1800"/>
+              <a:t>Priorizar municipios con señal de brote integrando morbilidad, vacunación, calidad del aire y acceso a salud — con IA explicable y revisión humana.</a:t>
             </a:r>
           </a:p>
         </p:txBody>
@@ -3276,7 +3284,7 @@
           <a:lstStyle/>
           <a:p>
             <a:r>
-              <a:t>Fuentes abiertas (datos.gov.co)</a:t>
+              <a:t>Datos abiertos</a:t>
             </a:r>
           </a:p>
         </p:txBody>
@@ -3297,32 +3305,45 @@
           <a:lstStyle/>
           <a:p>
             <a:r>
-              <a:rPr sz="2000"/>
+              <a:rPr sz="1800"/>
+              <a:t>Fuentes (datos.gov.co):</a:t>
+            </a:r>
+          </a:p>
+          <a:p>
+            <a:r>
+              <a:rPr sz="1800"/>
               <a:t>• SIVIGILA — casos semanales (dengue, hepatitis, chikungunya…)</a:t>
             </a:r>
           </a:p>
           <a:p>
             <a:r>
-              <a:rPr sz="2000"/>
-              <a:t>• Cobertura vacunal pentavalente (DPT-HepB-Hib)</a:t>
-            </a:r>
-          </a:p>
-          <a:p>
-            <a:r>
-              <a:rPr sz="2000"/>
-              <a:t>• PM2.5 promedio anual municipal (+ fallback SISAIRE)</a:t>
-            </a:r>
-          </a:p>
-          <a:p>
-            <a:r>
-              <a:rPr sz="2000"/>
-              <a:t>• Indicadores INS: mortalidad y partos institucionales</a:t>
-            </a:r>
-          </a:p>
-          <a:p>
-            <a:r>
-              <a:rPr sz="2000"/>
-              <a:t>• Catálogo DIVIPOLA para validación territorial</a:t>
+              <a:rPr sz="1800"/>
+              <a:t>• Vacunación pentavalente DPT-HepB-Hib</a:t>
+            </a:r>
+          </a:p>
+          <a:p>
+            <a:r>
+              <a:rPr sz="1800"/>
+              <a:t>• PM2.5 anual municipal (+ fallback SISAIRE)</a:t>
+            </a:r>
+          </a:p>
+          <a:p>
+            <a:r>
+              <a:rPr sz="1800"/>
+              <a:t>• INS: mortalidad y partos institucionales</a:t>
+            </a:r>
+          </a:p>
+          <a:p/>
+          <a:p>
+            <a:r>
+              <a:rPr sz="1800"/>
+              <a:t>Tratamiento:</a:t>
+            </a:r>
+          </a:p>
+          <a:p>
+            <a:r>
+              <a:rPr sz="1800"/>
+              <a:t>20 ciudades · ~9.000 observaciones curadas · 15 variables ML · validación DIVIPOLA · ingestión trazable en PostgreSQL</a:t>
             </a:r>
           </a:p>
         </p:txBody>
@@ -3361,7 +3382,7 @@
           <a:lstStyle/>
           <a:p>
             <a:r>
-              <a:t>Arquitectura</a:t>
+              <a:t>Solución e IA</a:t>
             </a:r>
           </a:p>
         </p:txBody>
@@ -3382,26 +3403,38 @@
           <a:lstStyle/>
           <a:p>
             <a:r>
-              <a:rPr sz="2000"/>
-              <a:t>Backend FastAPI (DDD) + PostgreSQL + ML explicable</a:t>
-            </a:r>
-          </a:p>
-          <a:p>
-            <a:r>
-              <a:rPr sz="2000"/>
-              <a:t>Frontend Next.js: mapa, alertas, informe territorial</a:t>
-            </a:r>
-          </a:p>
-          <a:p>
-            <a:r>
-              <a:rPr sz="2000"/>
-              <a:t>Ingestión programada desde datos.gov.co con trazabilidad</a:t>
-            </a:r>
-          </a:p>
-          <a:p>
-            <a:r>
-              <a:rPr sz="2000"/>
-              <a:t>Docker Compose para despliegue reproducible</a:t>
+              <a:rPr sz="1800"/>
+              <a:t>Plataforma modular (FastAPI + Next.js + Docker):</a:t>
+            </a:r>
+          </a:p>
+          <a:p>
+            <a:r>
+              <a:rPr sz="1800"/>
+              <a:t>• Ingestión desde datos.gov.co con token Socrata</a:t>
+            </a:r>
+          </a:p>
+          <a:p>
+            <a:r>
+              <a:rPr sz="1800"/>
+              <a:t>• Modelo Random Forest + SHAP TreeExplainer</a:t>
+            </a:r>
+          </a:p>
+          <a:p>
+            <a:r>
+              <a:rPr sz="1800"/>
+              <a:t>• Panel: municipio × semana epidemiológica × dengue</a:t>
+            </a:r>
+          </a:p>
+          <a:p>
+            <a:r>
+              <a:rPr sz="1800"/>
+              <a:t>• Validación temporal: entrenamiento ≤2020, prueba ≥2021</a:t>
+            </a:r>
+          </a:p>
+          <a:p>
+            <a:r>
+              <a:rPr sz="1800"/>
+              <a:t>• Fallback rule-based auditable si no hay modelo promovido</a:t>
             </a:r>
           </a:p>
         </p:txBody>
@@ -3440,7 +3473,7 @@
           <a:lstStyle/>
           <a:p>
             <a:r>
-              <a:t>Modelo de IA — 15 variables</a:t>
+              <a:t>Resultados y demo</a:t>
             </a:r>
           </a:p>
         </p:txBody>
@@ -3461,26 +3494,57 @@
           <a:lstStyle/>
           <a:p>
             <a:r>
-              <a:rPr sz="2000"/>
-              <a:t>Random Forest + SHAP TreeExplainer</a:t>
-            </a:r>
-          </a:p>
-          <a:p>
-            <a:r>
-              <a:rPr sz="2000"/>
-              <a:t>Panel: municipio × semana epidemiológica × dengue</a:t>
-            </a:r>
-          </a:p>
-          <a:p>
-            <a:r>
-              <a:rPr sz="2000"/>
-              <a:t>Features: casos, crecimiento, vacunación, PM2.5, acceso a salud, estacionalidad</a:t>
-            </a:r>
-          </a:p>
-          <a:p>
-            <a:r>
-              <a:rPr sz="2000"/>
-              <a:t>Validación temporal: entrenamiento ≤2020, prueba ≥2021</a:t>
+              <a:rPr sz="1800"/>
+              <a:t>Modelo promovido: randomforest-outbreak-v1.0.0</a:t>
+            </a:r>
+          </a:p>
+          <a:p>
+            <a:r>
+              <a:rPr sz="1800"/>
+              <a:t>• 3781 muestras de entrenamiento (dengue semanal)</a:t>
+            </a:r>
+          </a:p>
+          <a:p>
+            <a:r>
+              <a:rPr sz="1800"/>
+              <a:t>• Split temporal: train 2319 / test 1462</a:t>
+            </a:r>
+          </a:p>
+          <a:p>
+            <a:r>
+              <a:rPr sz="1800"/>
+              <a:t>• F1 1.0 · Recall 1.0 · ROC-AUC 1.0</a:t>
+            </a:r>
+          </a:p>
+          <a:p>
+            <a:r>
+              <a:rPr sz="1800"/>
+              <a:t>• Cautela: panel acotado; validación epidemiológica externa pendiente</a:t>
+            </a:r>
+          </a:p>
+          <a:p/>
+          <a:p>
+            <a:r>
+              <a:rPr sz="1800"/>
+              <a:t>Demo en vivo:</a:t>
+            </a:r>
+          </a:p>
+          <a:p>
+            <a:r>
+              <a:rPr sz="1800"/>
+              <a:t>• http://localhost:3002/brotes — señal y factores SHAP</a:t>
+            </a:r>
+          </a:p>
+          <a:p>
+            <a:r>
+              <a:rPr sz="1800"/>
+              <a:t>• /mapa — alertas territoriales · /informe — reporte imprimible</a:t>
+            </a:r>
+          </a:p>
+          <a:p>
+            <a:r>
+              <a:rPr sz="1800"/>
+              <a:t>• API: http://localhost:8000/docs</a:t>
             </a:r>
           </a:p>
         </p:txBody>
@@ -3519,7 +3583,7 @@
           <a:lstStyle/>
           <a:p>
             <a:r>
-              <a:t>Resultados del modelo</a:t>
+              <a:t>Impacto</a:t>
             </a:r>
           </a:p>
         </p:txBody>
@@ -3540,33 +3604,40 @@
           <a:lstStyle/>
           <a:p>
             <a:r>
-              <a:rPr sz="2000"/>
-              <a:t>Muestras de entrenamiento: 3781</a:t>
-            </a:r>
-          </a:p>
-          <a:p>
-            <a:r>
-              <a:rPr sz="2000"/>
-              <a:t>Train / test: 2319 / 1462</a:t>
-            </a:r>
-          </a:p>
-          <a:p>
-            <a:r>
-              <a:rPr sz="2000"/>
-              <a:t>F1: 1.0 · Recall: 1.0 · ROC-AUC: 1.0</a:t>
+              <a:rPr sz="1800"/>
+              <a:t>Beneficiarios: gestores de salud pública y vigilancia territorial</a:t>
             </a:r>
           </a:p>
           <a:p/>
           <a:p>
             <a:r>
-              <a:rPr sz="2000"/>
-              <a:t>Cobertura actual: 20 ciudades principales (~9.000 observaciones curadas)</a:t>
-            </a:r>
-          </a:p>
-          <a:p>
-            <a:r>
-              <a:rPr sz="2000"/>
-              <a:t>Nota: métricas altas en panel acotado; requiere validación epidemiológica externa.</a:t>
+              <a:rPr sz="1800"/>
+              <a:t>Valor público:</a:t>
+            </a:r>
+          </a:p>
+          <a:p>
+            <a:r>
+              <a:rPr sz="1800"/>
+              <a:t>• Priorización de territorios antes del pico de casos</a:t>
+            </a:r>
+          </a:p>
+          <a:p>
+            <a:r>
+              <a:rPr sz="1800"/>
+              <a:t>• Explicación clara de factores (no caja negra)</a:t>
+            </a:r>
+          </a:p>
+          <a:p>
+            <a:r>
+              <a:rPr sz="1800"/>
+              <a:t>• Reproducible con datos abiertos oficiales</a:t>
+            </a:r>
+          </a:p>
+          <a:p/>
+          <a:p>
+            <a:r>
+              <a:rPr sz="1800"/>
+              <a:t>Sostenibilidad: worker de ingestión, documentación, CI y despliegue Docker</a:t>
             </a:r>
           </a:p>
         </p:txBody>
@@ -3605,7 +3676,7 @@
           <a:lstStyle/>
           <a:p>
             <a:r>
-              <a:t>Demo en vivo</a:t>
+              <a:t>Repositorio y recursos</a:t>
             </a:r>
           </a:p>
         </p:txBody>
@@ -3626,26 +3697,45 @@
           <a:lstStyle/>
           <a:p>
             <a:r>
-              <a:rPr sz="2000"/>
-              <a:t>1. http://localhost:3002/brotes — señal y factores SHAP</a:t>
-            </a:r>
-          </a:p>
-          <a:p>
-            <a:r>
-              <a:rPr sz="2000"/>
-              <a:t>2. Mapa territorial de alertas</a:t>
-            </a:r>
-          </a:p>
-          <a:p>
-            <a:r>
-              <a:rPr sz="2000"/>
-              <a:t>3. Informe imprimible /informe</a:t>
-            </a:r>
-          </a:p>
-          <a:p>
-            <a:r>
-              <a:rPr sz="2000"/>
-              <a:t>4. API OpenAPI: http://localhost:8000/docs</a:t>
+              <a:rPr sz="1800"/>
+              <a:t>GitHub: https://github.com/luisrapalino/concurso-datos-abiertos-colombia-2026</a:t>
+            </a:r>
+          </a:p>
+          <a:p/>
+          <a:p>
+            <a:r>
+              <a:rPr sz="1800"/>
+              <a:t>Documentación clave:</a:t>
+            </a:r>
+          </a:p>
+          <a:p>
+            <a:r>
+              <a:rPr sz="1800"/>
+              <a:t>• README.md — ficha técnica y reproducción</a:t>
+            </a:r>
+          </a:p>
+          <a:p>
+            <a:r>
+              <a:rPr sz="1800"/>
+              <a:t>• docs/concurso-alignment.md — trazabilidad del reto</a:t>
+            </a:r>
+          </a:p>
+          <a:p>
+            <a:r>
+              <a:rPr sz="1800"/>
+              <a:t>• docs/data-dictionary.md — 15 variables</a:t>
+            </a:r>
+          </a:p>
+          <a:p>
+            <a:r>
+              <a:rPr sz="1800"/>
+              <a:t>• docs/ml-evaluation.md — validación y límites</a:t>
+            </a:r>
+          </a:p>
+          <a:p>
+            <a:r>
+              <a:rPr sz="1800"/>
+              <a:t>• RECURSOS/ — presentación y portada</a:t>
             </a:r>
           </a:p>
         </p:txBody>
@@ -3684,7 +3774,7 @@
           <a:lstStyle/>
           <a:p>
             <a:r>
-              <a:t>Impacto y límites</a:t>
+              <a:t>Cierre</a:t>
             </a:r>
           </a:p>
         </p:txBody>
@@ -3705,38 +3795,34 @@
           <a:lstStyle/>
           <a:p>
             <a:r>
-              <a:rPr sz="2000"/>
-              <a:t>Impacto: priorización territorial, explicabilidad para gestores de salud</a:t>
-            </a:r>
-          </a:p>
-          <a:p>
-            <a:r>
-              <a:rPr sz="2000"/>
-              <a:t>Límites honestos:</a:t>
-            </a:r>
-          </a:p>
-          <a:p>
-            <a:r>
-              <a:rPr sz="2000"/>
-              <a:t>• No activa respuestas automáticas</a:t>
-            </a:r>
-          </a:p>
-          <a:p>
-            <a:r>
-              <a:rPr sz="2000"/>
-              <a:t>• Vacunación replicada desde nivel departamental</a:t>
-            </a:r>
-          </a:p>
-          <a:p>
-            <a:r>
-              <a:rPr sz="2000"/>
-              <a:t>• PM2.5 solo donde hay estaciones</a:t>
-            </a:r>
-          </a:p>
-          <a:p>
-            <a:r>
-              <a:rPr sz="2000"/>
-              <a:t>• Cobertura parcial vs todo el territorio nacional</a:t>
+              <a:rPr sz="1800"/>
+              <a:t>Frase clave:</a:t>
+            </a:r>
+          </a:p>
+          <a:p>
+            <a:r>
+              <a:rPr sz="1800"/>
+              <a:t>Priorizamos municipios con riesgo de brote usando datos abiertos de Colombia e IA explicable.</a:t>
+            </a:r>
+          </a:p>
+          <a:p/>
+          <a:p>
+            <a:r>
+              <a:rPr sz="1800"/>
+              <a:t>Valor diferencial:</a:t>
+            </a:r>
+          </a:p>
+          <a:p>
+            <a:r>
+              <a:rPr sz="1800"/>
+              <a:t>Integración multifuente + explicabilidad SHAP + plataforma demostrable en 10 minutos.</a:t>
+            </a:r>
+          </a:p>
+          <a:p/>
+          <a:p>
+            <a:r>
+              <a:rPr sz="1800"/>
+              <a:t>Gracias — preguntas técnicas bienvenidas.</a:t>
             </a:r>
           </a:p>
         </p:txBody>

</xml_diff>

<commit_message>
chore(concurso): add live demo screenshots and regenerate deck
Include brotes, mapa and landing captures from production and rebuild
presentation assets with the new demo slide.
</commit_message>
<xml_diff>
--- a/RECURSOS/Presentacion.pptx
+++ b/RECURSOS/Presentacion.pptx
@@ -13,6 +13,7 @@
     <p:sldId id="261" r:id="rId12"/>
     <p:sldId id="262" r:id="rId13"/>
     <p:sldId id="263" r:id="rId14"/>
+    <p:sldId id="264" r:id="rId15"/>
   </p:sldIdLst>
   <p:sldSz cx="12191695" cy="6858000" type="screen4x3"/>
   <p:notesSz cx="6858000" cy="9144000"/>
@@ -6725,7 +6726,7 @@
                   <a:srgbClr val="5EEAD4"/>
                 </a:solidFill>
               </a:rPr>
-              <a:t>IMPACTO</a:t>
+              <a:t>DEMO</a:t>
             </a:r>
           </a:p>
         </p:txBody>
@@ -6761,7 +6762,7 @@
               </a:defRPr>
             </a:pPr>
             <a:r>
-              <a:t>Impacto y sostenibilidad</a:t>
+              <a:t>Plataforma en producción</a:t>
             </a:r>
           </a:p>
         </p:txBody>
@@ -6809,8 +6810,8 @@
         </p:nvSpPr>
         <p:spPr>
           <a:xfrm>
-            <a:off x="548640" y="1828800"/>
-            <a:ext cx="11064240" cy="822960"/>
+            <a:off x="548640" y="1417320"/>
+            <a:ext cx="5440680" cy="4160520"/>
           </a:xfrm>
           <a:prstGeom prst="roundRect">
             <a:avLst>
@@ -6857,14 +6858,14 @@
         </p:nvSpPr>
         <p:spPr>
           <a:xfrm>
-            <a:off x="548640" y="1960473"/>
-            <a:ext cx="309798" cy="559612"/>
+            <a:off x="548640" y="2083003"/>
+            <a:ext cx="152339" cy="2829153"/>
           </a:xfrm>
           <a:prstGeom prst="rect">
             <a:avLst/>
           </a:prstGeom>
           <a:solidFill>
-            <a:srgbClr val="5EEAD4"/>
+            <a:srgbClr val="0A5C54"/>
           </a:solidFill>
           <a:ln>
             <a:noFill/>
@@ -6892,41 +6893,30 @@
           </a:p>
         </p:txBody>
       </p:sp>
-      <p:sp>
-        <p:nvSpPr>
-          <p:cNvPr id="8" name="TextBox 7"/>
-          <p:cNvSpPr txBox="1"/>
-          <p:nvPr/>
-        </p:nvSpPr>
-        <p:spPr>
-          <a:xfrm>
-            <a:off x="868680" y="1975104"/>
-            <a:ext cx="10424160" cy="640080"/>
-          </a:xfrm>
-          <a:prstGeom prst="rect">
-            <a:avLst/>
-          </a:prstGeom>
-          <a:noFill/>
-        </p:spPr>
-        <p:txBody>
-          <a:bodyPr wrap="square">
-            <a:spAutoFit/>
-          </a:bodyPr>
-          <a:lstStyle/>
-          <a:p>
-            <a:pPr>
-              <a:defRPr sz="1600" b="1">
-                <a:solidFill>
-                  <a:srgbClr val="0A5C54"/>
-                </a:solidFill>
-              </a:defRPr>
-            </a:pPr>
-            <a:r>
-              <a:t>Valor público: prevención y respuesta temprana con trazabilidad</a:t>
-            </a:r>
-          </a:p>
-        </p:txBody>
-      </p:sp>
+      <p:pic>
+        <p:nvPicPr>
+          <p:cNvPr id="8" name="Picture 7" descr="brotes.png"/>
+          <p:cNvPicPr>
+            <a:picLocks noChangeAspect="1"/>
+          </p:cNvPicPr>
+          <p:nvPr/>
+        </p:nvPicPr>
+        <p:blipFill>
+          <a:blip r:embed="rId3"/>
+          <a:stretch>
+            <a:fillRect/>
+          </a:stretch>
+        </p:blipFill>
+        <p:spPr>
+          <a:xfrm>
+            <a:off x="621792" y="1527048"/>
+            <a:ext cx="5294376" cy="3657600"/>
+          </a:xfrm>
+          <a:prstGeom prst="rect">
+            <a:avLst/>
+          </a:prstGeom>
+        </p:spPr>
+      </p:pic>
       <p:sp>
         <p:nvSpPr>
           <p:cNvPr id="9" name="TextBox 8"/>
@@ -6935,136 +6925,8 @@
         </p:nvSpPr>
         <p:spPr>
           <a:xfrm>
-            <a:off x="822960" y="2926080"/>
-            <a:ext cx="10515600" cy="4023360"/>
-          </a:xfrm>
-          <a:prstGeom prst="rect">
-            <a:avLst/>
-          </a:prstGeom>
-          <a:noFill/>
-        </p:spPr>
-        <p:txBody>
-          <a:bodyPr wrap="square">
-            <a:spAutoFit/>
-          </a:bodyPr>
-          <a:lstStyle/>
-          <a:p>
-            <a:pPr>
-              <a:spcAft>
-                <a:spcPts val="1000"/>
-              </a:spcAft>
-              <a:defRPr sz="1700">
-                <a:solidFill>
-                  <a:srgbClr val="142824"/>
-                </a:solidFill>
-                <a:latin typeface="Calibri"/>
-              </a:defRPr>
-            </a:pPr>
-            <a:r>
-              <a:rPr>
-                <a:solidFill>
-                  <a:srgbClr val="5EEAD4"/>
-                </a:solidFill>
-              </a:rPr>
-              <a:t>■  Beneficiarios: equipos de vigilancia en salud pública y gestión territorial</a:t>
-            </a:r>
-          </a:p>
-          <a:p>
-            <a:pPr>
-              <a:spcAft>
-                <a:spcPts val="1000"/>
-              </a:spcAft>
-              <a:defRPr sz="1700">
-                <a:solidFill>
-                  <a:srgbClr val="142824"/>
-                </a:solidFill>
-                <a:latin typeface="Calibri"/>
-              </a:defRPr>
-            </a:pPr>
-            <a:r>
-              <a:rPr>
-                <a:solidFill>
-                  <a:srgbClr val="5EEAD4"/>
-                </a:solidFill>
-              </a:rPr>
-              <a:t>■  Permite focalizar recursos antes del pico de casos</a:t>
-            </a:r>
-          </a:p>
-          <a:p>
-            <a:pPr>
-              <a:spcAft>
-                <a:spcPts val="1000"/>
-              </a:spcAft>
-              <a:defRPr sz="1700">
-                <a:solidFill>
-                  <a:srgbClr val="142824"/>
-                </a:solidFill>
-                <a:latin typeface="Calibri"/>
-              </a:defRPr>
-            </a:pPr>
-            <a:r>
-              <a:rPr>
-                <a:solidFill>
-                  <a:srgbClr val="5EEAD4"/>
-                </a:solidFill>
-              </a:rPr>
-              <a:t>■  Explicación clara de factores — evita caja negra</a:t>
-            </a:r>
-          </a:p>
-          <a:p>
-            <a:pPr>
-              <a:spcAft>
-                <a:spcPts val="1000"/>
-              </a:spcAft>
-              <a:defRPr sz="1700">
-                <a:solidFill>
-                  <a:srgbClr val="142824"/>
-                </a:solidFill>
-                <a:latin typeface="Calibri"/>
-              </a:defRPr>
-            </a:pPr>
-            <a:r>
-              <a:rPr>
-                <a:solidFill>
-                  <a:srgbClr val="5EEAD4"/>
-                </a:solidFill>
-              </a:rPr>
-              <a:t>■  Reproducible con datos abiertos oficiales de Colombia</a:t>
-            </a:r>
-          </a:p>
-          <a:p>
-            <a:pPr>
-              <a:spcAft>
-                <a:spcPts val="1000"/>
-              </a:spcAft>
-              <a:defRPr sz="1700">
-                <a:solidFill>
-                  <a:srgbClr val="142824"/>
-                </a:solidFill>
-                <a:latin typeface="Calibri"/>
-              </a:defRPr>
-            </a:pPr>
-            <a:r>
-              <a:rPr>
-                <a:solidFill>
-                  <a:srgbClr val="5EEAD4"/>
-                </a:solidFill>
-              </a:rPr>
-              <a:t>■  Sostenibilidad: ingestión automática, documentación, CI y despliegue Docker</a:t>
-            </a:r>
-          </a:p>
-        </p:txBody>
-      </p:sp>
-      <p:sp>
-        <p:nvSpPr>
-          <p:cNvPr id="10" name="TextBox 9"/>
-          <p:cNvSpPr txBox="1"/>
-          <p:nvPr/>
-        </p:nvSpPr>
-        <p:spPr>
-          <a:xfrm>
-            <a:off x="548640" y="6473952"/>
-            <a:ext cx="8229600" cy="320040"/>
+            <a:off x="658368" y="5239512"/>
+            <a:ext cx="5221224" cy="320040"/>
           </a:xfrm>
           <a:prstGeom prst="rect">
             <a:avLst/>
@@ -7078,6 +6940,226 @@
           <a:lstStyle/>
           <a:p>
             <a:pPr>
+              <a:defRPr sz="1100" b="1">
+                <a:solidFill>
+                  <a:srgbClr val="5C6F6B"/>
+                </a:solidFill>
+              </a:defRPr>
+            </a:pPr>
+            <a:r>
+              <a:t>Ficha territorial · señal y explicación SHAP</a:t>
+            </a:r>
+          </a:p>
+        </p:txBody>
+      </p:sp>
+      <p:sp>
+        <p:nvSpPr>
+          <p:cNvPr id="10" name="Rounded Rectangle 9"/>
+          <p:cNvSpPr/>
+          <p:nvPr/>
+        </p:nvSpPr>
+        <p:spPr>
+          <a:xfrm>
+            <a:off x="6172200" y="1417320"/>
+            <a:ext cx="5440680" cy="4160520"/>
+          </a:xfrm>
+          <a:prstGeom prst="roundRect">
+            <a:avLst>
+              <a:gd name="adj" fmla="val 6000"/>
+            </a:avLst>
+          </a:prstGeom>
+          <a:solidFill>
+            <a:srgbClr val="FAFCFB"/>
+          </a:solidFill>
+          <a:ln w="9525">
+            <a:solidFill>
+              <a:srgbClr val="C8D9D4"/>
+            </a:solidFill>
+          </a:ln>
+          <a:effectLst/>
+        </p:spPr>
+        <p:style>
+          <a:lnRef idx="1">
+            <a:schemeClr val="accent1"/>
+          </a:lnRef>
+          <a:fillRef idx="3">
+            <a:schemeClr val="accent1"/>
+          </a:fillRef>
+          <a:effectRef idx="2">
+            <a:schemeClr val="accent1"/>
+          </a:effectRef>
+          <a:fontRef idx="minor">
+            <a:schemeClr val="lt1"/>
+          </a:fontRef>
+        </p:style>
+        <p:txBody>
+          <a:bodyPr rtlCol="0" anchor="ctr"/>
+          <a:lstStyle/>
+          <a:p>
+            <a:pPr algn="ctr"/>
+          </a:p>
+        </p:txBody>
+      </p:sp>
+      <p:sp>
+        <p:nvSpPr>
+          <p:cNvPr id="11" name="Rectangle 10"/>
+          <p:cNvSpPr/>
+          <p:nvPr/>
+        </p:nvSpPr>
+        <p:spPr>
+          <a:xfrm>
+            <a:off x="6172200" y="2083003"/>
+            <a:ext cx="152339" cy="2829153"/>
+          </a:xfrm>
+          <a:prstGeom prst="rect">
+            <a:avLst/>
+          </a:prstGeom>
+          <a:solidFill>
+            <a:srgbClr val="0A5C54"/>
+          </a:solidFill>
+          <a:ln>
+            <a:noFill/>
+          </a:ln>
+        </p:spPr>
+        <p:style>
+          <a:lnRef idx="1">
+            <a:schemeClr val="accent1"/>
+          </a:lnRef>
+          <a:fillRef idx="3">
+            <a:schemeClr val="accent1"/>
+          </a:fillRef>
+          <a:effectRef idx="2">
+            <a:schemeClr val="accent1"/>
+          </a:effectRef>
+          <a:fontRef idx="minor">
+            <a:schemeClr val="lt1"/>
+          </a:fontRef>
+        </p:style>
+        <p:txBody>
+          <a:bodyPr rtlCol="0" anchor="ctr"/>
+          <a:lstStyle/>
+          <a:p>
+            <a:pPr algn="ctr"/>
+          </a:p>
+        </p:txBody>
+      </p:sp>
+      <p:pic>
+        <p:nvPicPr>
+          <p:cNvPr id="12" name="Picture 11" descr="mapa.png"/>
+          <p:cNvPicPr>
+            <a:picLocks noChangeAspect="1"/>
+          </p:cNvPicPr>
+          <p:nvPr/>
+        </p:nvPicPr>
+        <p:blipFill>
+          <a:blip r:embed="rId4"/>
+          <a:stretch>
+            <a:fillRect/>
+          </a:stretch>
+        </p:blipFill>
+        <p:spPr>
+          <a:xfrm>
+            <a:off x="6245352" y="1527048"/>
+            <a:ext cx="5294376" cy="3657600"/>
+          </a:xfrm>
+          <a:prstGeom prst="rect">
+            <a:avLst/>
+          </a:prstGeom>
+        </p:spPr>
+      </p:pic>
+      <p:sp>
+        <p:nvSpPr>
+          <p:cNvPr id="13" name="TextBox 12"/>
+          <p:cNvSpPr txBox="1"/>
+          <p:nvPr/>
+        </p:nvSpPr>
+        <p:spPr>
+          <a:xfrm>
+            <a:off x="6281928" y="5239512"/>
+            <a:ext cx="5221224" cy="320040"/>
+          </a:xfrm>
+          <a:prstGeom prst="rect">
+            <a:avLst/>
+          </a:prstGeom>
+          <a:noFill/>
+        </p:spPr>
+        <p:txBody>
+          <a:bodyPr wrap="none">
+            <a:spAutoFit/>
+          </a:bodyPr>
+          <a:lstStyle/>
+          <a:p>
+            <a:pPr>
+              <a:defRPr sz="1100" b="1">
+                <a:solidFill>
+                  <a:srgbClr val="5C6F6B"/>
+                </a:solidFill>
+              </a:defRPr>
+            </a:pPr>
+            <a:r>
+              <a:t>Mapa de señales · 20 ciudades principales</a:t>
+            </a:r>
+          </a:p>
+        </p:txBody>
+      </p:sp>
+      <p:sp>
+        <p:nvSpPr>
+          <p:cNvPr id="14" name="TextBox 13"/>
+          <p:cNvSpPr txBox="1"/>
+          <p:nvPr/>
+        </p:nvSpPr>
+        <p:spPr>
+          <a:xfrm>
+            <a:off x="685800" y="5806440"/>
+            <a:ext cx="10789920" cy="411480"/>
+          </a:xfrm>
+          <a:prstGeom prst="rect">
+            <a:avLst/>
+          </a:prstGeom>
+          <a:noFill/>
+        </p:spPr>
+        <p:txBody>
+          <a:bodyPr wrap="none">
+            <a:spAutoFit/>
+          </a:bodyPr>
+          <a:lstStyle/>
+          <a:p>
+            <a:pPr>
+              <a:defRPr sz="1000">
+                <a:solidFill>
+                  <a:srgbClr val="0A5C54"/>
+                </a:solidFill>
+              </a:defRPr>
+            </a:pPr>
+            <a:r>
+              <a:t>https://concurso-datos-abiertos-colombia-20.vercel.app  ·  https://concurso-datos-abiertos-colombia-20.vercel.app/brotes</a:t>
+            </a:r>
+          </a:p>
+        </p:txBody>
+      </p:sp>
+      <p:sp>
+        <p:nvSpPr>
+          <p:cNvPr id="15" name="TextBox 14"/>
+          <p:cNvSpPr txBox="1"/>
+          <p:nvPr/>
+        </p:nvSpPr>
+        <p:spPr>
+          <a:xfrm>
+            <a:off x="548640" y="6473952"/>
+            <a:ext cx="8229600" cy="320040"/>
+          </a:xfrm>
+          <a:prstGeom prst="rect">
+            <a:avLst/>
+          </a:prstGeom>
+          <a:noFill/>
+        </p:spPr>
+        <p:txBody>
+          <a:bodyPr wrap="none">
+            <a:spAutoFit/>
+          </a:bodyPr>
+          <a:lstStyle/>
+          <a:p>
+            <a:pPr>
               <a:defRPr sz="900">
                 <a:solidFill>
                   <a:srgbClr val="5C6F6B"/>
@@ -7092,7 +7174,7 @@
       </p:sp>
       <p:sp>
         <p:nvSpPr>
-          <p:cNvPr id="11" name="TextBox 10"/>
+          <p:cNvPr id="16" name="TextBox 15"/>
           <p:cNvSpPr txBox="1"/>
           <p:nvPr/>
         </p:nvSpPr>
@@ -7203,7 +7285,7 @@
                   <a:srgbClr val="5EEAD4"/>
                 </a:solidFill>
               </a:rPr>
-              <a:t>ENTREGABLES</a:t>
+              <a:t>IMPACTO</a:t>
             </a:r>
           </a:p>
         </p:txBody>
@@ -7239,7 +7321,7 @@
               </a:defRPr>
             </a:pPr>
             <a:r>
-              <a:t>Repositorio y recursos</a:t>
+              <a:t>Impacto y sostenibilidad</a:t>
             </a:r>
           </a:p>
         </p:txBody>
@@ -7281,13 +7363,139 @@
       </p:sp>
       <p:sp>
         <p:nvSpPr>
-          <p:cNvPr id="6" name="TextBox 5"/>
+          <p:cNvPr id="6" name="Rounded Rectangle 5"/>
+          <p:cNvSpPr/>
+          <p:nvPr/>
+        </p:nvSpPr>
+        <p:spPr>
+          <a:xfrm>
+            <a:off x="548640" y="1828800"/>
+            <a:ext cx="11064240" cy="822960"/>
+          </a:xfrm>
+          <a:prstGeom prst="roundRect">
+            <a:avLst>
+              <a:gd name="adj" fmla="val 6000"/>
+            </a:avLst>
+          </a:prstGeom>
+          <a:solidFill>
+            <a:srgbClr val="FAFCFB"/>
+          </a:solidFill>
+          <a:ln w="9525">
+            <a:solidFill>
+              <a:srgbClr val="C8D9D4"/>
+            </a:solidFill>
+          </a:ln>
+          <a:effectLst/>
+        </p:spPr>
+        <p:style>
+          <a:lnRef idx="1">
+            <a:schemeClr val="accent1"/>
+          </a:lnRef>
+          <a:fillRef idx="3">
+            <a:schemeClr val="accent1"/>
+          </a:fillRef>
+          <a:effectRef idx="2">
+            <a:schemeClr val="accent1"/>
+          </a:effectRef>
+          <a:fontRef idx="minor">
+            <a:schemeClr val="lt1"/>
+          </a:fontRef>
+        </p:style>
+        <p:txBody>
+          <a:bodyPr rtlCol="0" anchor="ctr"/>
+          <a:lstStyle/>
+          <a:p>
+            <a:pPr algn="ctr"/>
+          </a:p>
+        </p:txBody>
+      </p:sp>
+      <p:sp>
+        <p:nvSpPr>
+          <p:cNvPr id="7" name="Rectangle 6"/>
+          <p:cNvSpPr/>
+          <p:nvPr/>
+        </p:nvSpPr>
+        <p:spPr>
+          <a:xfrm>
+            <a:off x="548640" y="1960473"/>
+            <a:ext cx="309798" cy="559612"/>
+          </a:xfrm>
+          <a:prstGeom prst="rect">
+            <a:avLst/>
+          </a:prstGeom>
+          <a:solidFill>
+            <a:srgbClr val="5EEAD4"/>
+          </a:solidFill>
+          <a:ln>
+            <a:noFill/>
+          </a:ln>
+        </p:spPr>
+        <p:style>
+          <a:lnRef idx="1">
+            <a:schemeClr val="accent1"/>
+          </a:lnRef>
+          <a:fillRef idx="3">
+            <a:schemeClr val="accent1"/>
+          </a:fillRef>
+          <a:effectRef idx="2">
+            <a:schemeClr val="accent1"/>
+          </a:effectRef>
+          <a:fontRef idx="minor">
+            <a:schemeClr val="lt1"/>
+          </a:fontRef>
+        </p:style>
+        <p:txBody>
+          <a:bodyPr rtlCol="0" anchor="ctr"/>
+          <a:lstStyle/>
+          <a:p>
+            <a:pPr algn="ctr"/>
+          </a:p>
+        </p:txBody>
+      </p:sp>
+      <p:sp>
+        <p:nvSpPr>
+          <p:cNvPr id="8" name="TextBox 7"/>
           <p:cNvSpPr txBox="1"/>
           <p:nvPr/>
         </p:nvSpPr>
         <p:spPr>
           <a:xfrm>
-            <a:off x="822960" y="1965960"/>
+            <a:off x="868680" y="1975104"/>
+            <a:ext cx="10424160" cy="640080"/>
+          </a:xfrm>
+          <a:prstGeom prst="rect">
+            <a:avLst/>
+          </a:prstGeom>
+          <a:noFill/>
+        </p:spPr>
+        <p:txBody>
+          <a:bodyPr wrap="square">
+            <a:spAutoFit/>
+          </a:bodyPr>
+          <a:lstStyle/>
+          <a:p>
+            <a:pPr>
+              <a:defRPr sz="1600" b="1">
+                <a:solidFill>
+                  <a:srgbClr val="0A5C54"/>
+                </a:solidFill>
+              </a:defRPr>
+            </a:pPr>
+            <a:r>
+              <a:t>Valor público: prevención y respuesta temprana con trazabilidad</a:t>
+            </a:r>
+          </a:p>
+        </p:txBody>
+      </p:sp>
+      <p:sp>
+        <p:nvSpPr>
+          <p:cNvPr id="9" name="TextBox 8"/>
+          <p:cNvSpPr txBox="1"/>
+          <p:nvPr/>
+        </p:nvSpPr>
+        <p:spPr>
+          <a:xfrm>
+            <a:off x="822960" y="2926080"/>
             <a:ext cx="10515600" cy="4023360"/>
           </a:xfrm>
           <a:prstGeom prst="rect">
@@ -7318,7 +7526,7 @@
                   <a:srgbClr val="5EEAD4"/>
                 </a:solidFill>
               </a:rPr>
-              <a:t>■  GitHub: https://github.com/luisrapalino/concurso-datos-abiertos-colombia-2026</a:t>
+              <a:t>■  Beneficiarios: equipos de vigilancia en salud pública y gestión territorial</a:t>
             </a:r>
           </a:p>
           <a:p>
@@ -7339,7 +7547,7 @@
                   <a:srgbClr val="5EEAD4"/>
                 </a:solidFill>
               </a:rPr>
-              <a:t>■  README.md — ficha técnica y guía de reproducción</a:t>
+              <a:t>■  Permite focalizar recursos antes del pico de casos</a:t>
             </a:r>
           </a:p>
           <a:p>
@@ -7360,7 +7568,7 @@
                   <a:srgbClr val="5EEAD4"/>
                 </a:solidFill>
               </a:rPr>
-              <a:t>■  docs/concurso-alignment.md — trazabilidad del reto</a:t>
+              <a:t>■  Explicación clara de factores — evita caja negra</a:t>
             </a:r>
           </a:p>
           <a:p>
@@ -7381,7 +7589,7 @@
                   <a:srgbClr val="5EEAD4"/>
                 </a:solidFill>
               </a:rPr>
-              <a:t>■  docs/data-dictionary.md — 15 variables del modelo</a:t>
+              <a:t>■  Reproducible con datos abiertos oficiales de Colombia</a:t>
             </a:r>
           </a:p>
           <a:p>
@@ -7402,35 +7610,14 @@
                   <a:srgbClr val="5EEAD4"/>
                 </a:solidFill>
               </a:rPr>
-              <a:t>■  docs/ml-evaluation.md — validación, métricas y límites</a:t>
-            </a:r>
-          </a:p>
-          <a:p>
-            <a:pPr>
-              <a:spcAft>
-                <a:spcPts val="1000"/>
-              </a:spcAft>
-              <a:defRPr sz="1700">
-                <a:solidFill>
-                  <a:srgbClr val="142824"/>
-                </a:solidFill>
-                <a:latin typeface="Calibri"/>
-              </a:defRPr>
-            </a:pPr>
-            <a:r>
-              <a:rPr>
-                <a:solidFill>
-                  <a:srgbClr val="5EEAD4"/>
-                </a:solidFill>
-              </a:rPr>
-              <a:t>■  RECURSOS/ — presentación, PDF y portada</a:t>
-            </a:r>
-          </a:p>
-        </p:txBody>
-      </p:sp>
-      <p:sp>
-        <p:nvSpPr>
-          <p:cNvPr id="7" name="TextBox 6"/>
+              <a:t>■  Sostenibilidad: ingestión automática, documentación, CI y despliegue Docker</a:t>
+            </a:r>
+          </a:p>
+        </p:txBody>
+      </p:sp>
+      <p:sp>
+        <p:nvSpPr>
+          <p:cNvPr id="10" name="TextBox 9"/>
           <p:cNvSpPr txBox="1"/>
           <p:nvPr/>
         </p:nvSpPr>
@@ -7465,7 +7652,7 @@
       </p:sp>
       <p:sp>
         <p:nvSpPr>
-          <p:cNvPr id="8" name="TextBox 7"/>
+          <p:cNvPr id="11" name="TextBox 10"/>
           <p:cNvSpPr txBox="1"/>
           <p:nvPr/>
         </p:nvSpPr>
@@ -7507,6 +7694,379 @@
 </file>
 
 <file path=ppt/slides/slide8.xml><?xml version="1.0" encoding="utf-8"?>
+<p:sld xmlns:a="http://schemas.openxmlformats.org/drawingml/2006/main" xmlns:p="http://schemas.openxmlformats.org/presentationml/2006/main" xmlns:r="http://schemas.openxmlformats.org/officeDocument/2006/relationships">
+  <p:cSld>
+    <p:bg>
+      <p:bgPr>
+        <a:solidFill>
+          <a:srgbClr val="F0F5F3"/>
+        </a:solidFill>
+        <a:effectLst/>
+      </p:bgPr>
+    </p:bg>
+    <p:spTree>
+      <p:nvGrpSpPr>
+        <p:cNvPr id="1" name=""/>
+        <p:cNvGrpSpPr/>
+        <p:nvPr/>
+      </p:nvGrpSpPr>
+      <p:grpSpPr/>
+      <p:pic>
+        <p:nvPicPr>
+          <p:cNvPr id="2" name="Picture 1" descr=".bg-content.png"/>
+          <p:cNvPicPr>
+            <a:picLocks noChangeAspect="1"/>
+          </p:cNvPicPr>
+          <p:nvPr/>
+        </p:nvPicPr>
+        <p:blipFill>
+          <a:blip r:embed="rId2"/>
+          <a:stretch>
+            <a:fillRect/>
+          </a:stretch>
+        </p:blipFill>
+        <p:spPr>
+          <a:xfrm>
+            <a:off x="0" y="0"/>
+            <a:ext cx="12191695" cy="6858000"/>
+          </a:xfrm>
+          <a:prstGeom prst="rect">
+            <a:avLst/>
+          </a:prstGeom>
+        </p:spPr>
+      </p:pic>
+      <p:sp>
+        <p:nvSpPr>
+          <p:cNvPr id="3" name="TextBox 2"/>
+          <p:cNvSpPr txBox="1"/>
+          <p:nvPr/>
+        </p:nvSpPr>
+        <p:spPr>
+          <a:xfrm>
+            <a:off x="548640" y="146304"/>
+            <a:ext cx="8229600" cy="320040"/>
+          </a:xfrm>
+          <a:prstGeom prst="rect">
+            <a:avLst/>
+          </a:prstGeom>
+          <a:noFill/>
+        </p:spPr>
+        <p:txBody>
+          <a:bodyPr wrap="none">
+            <a:spAutoFit/>
+          </a:bodyPr>
+          <a:lstStyle/>
+          <a:p>
+            <a:r>
+              <a:rPr sz="1100" b="1">
+                <a:solidFill>
+                  <a:srgbClr val="5EEAD4"/>
+                </a:solidFill>
+              </a:rPr>
+              <a:t>ENTREGABLES</a:t>
+            </a:r>
+          </a:p>
+        </p:txBody>
+      </p:sp>
+      <p:sp>
+        <p:nvSpPr>
+          <p:cNvPr id="4" name="TextBox 3"/>
+          <p:cNvSpPr txBox="1"/>
+          <p:nvPr/>
+        </p:nvSpPr>
+        <p:spPr>
+          <a:xfrm>
+            <a:off x="548640" y="457200"/>
+            <a:ext cx="9601200" cy="685800"/>
+          </a:xfrm>
+          <a:prstGeom prst="rect">
+            <a:avLst/>
+          </a:prstGeom>
+          <a:noFill/>
+        </p:spPr>
+        <p:txBody>
+          <a:bodyPr wrap="none">
+            <a:spAutoFit/>
+          </a:bodyPr>
+          <a:lstStyle/>
+          <a:p>
+            <a:pPr>
+              <a:defRPr sz="3000" b="1">
+                <a:solidFill>
+                  <a:srgbClr val="FFFFFF"/>
+                </a:solidFill>
+                <a:latin typeface="Calibri"/>
+              </a:defRPr>
+            </a:pPr>
+            <a:r>
+              <a:t>Repositorio y recursos</a:t>
+            </a:r>
+          </a:p>
+        </p:txBody>
+      </p:sp>
+      <p:sp>
+        <p:nvSpPr>
+          <p:cNvPr id="5" name="TextBox 4"/>
+          <p:cNvSpPr txBox="1"/>
+          <p:nvPr/>
+        </p:nvSpPr>
+        <p:spPr>
+          <a:xfrm>
+            <a:off x="10424160" y="310896"/>
+            <a:ext cx="1463040" cy="548640"/>
+          </a:xfrm>
+          <a:prstGeom prst="rect">
+            <a:avLst/>
+          </a:prstGeom>
+          <a:noFill/>
+        </p:spPr>
+        <p:txBody>
+          <a:bodyPr wrap="none">
+            <a:spAutoFit/>
+          </a:bodyPr>
+          <a:lstStyle/>
+          <a:p>
+            <a:pPr algn="ctr">
+              <a:defRPr sz="2400" b="1">
+                <a:solidFill>
+                  <a:srgbClr val="5EEAD4"/>
+                </a:solidFill>
+              </a:defRPr>
+            </a:pPr>
+            <a:r>
+              <a:t>07</a:t>
+            </a:r>
+          </a:p>
+        </p:txBody>
+      </p:sp>
+      <p:sp>
+        <p:nvSpPr>
+          <p:cNvPr id="6" name="TextBox 5"/>
+          <p:cNvSpPr txBox="1"/>
+          <p:nvPr/>
+        </p:nvSpPr>
+        <p:spPr>
+          <a:xfrm>
+            <a:off x="822960" y="1965960"/>
+            <a:ext cx="10515600" cy="4023360"/>
+          </a:xfrm>
+          <a:prstGeom prst="rect">
+            <a:avLst/>
+          </a:prstGeom>
+          <a:noFill/>
+        </p:spPr>
+        <p:txBody>
+          <a:bodyPr wrap="square">
+            <a:spAutoFit/>
+          </a:bodyPr>
+          <a:lstStyle/>
+          <a:p>
+            <a:pPr>
+              <a:spcAft>
+                <a:spcPts val="1000"/>
+              </a:spcAft>
+              <a:defRPr sz="1700">
+                <a:solidFill>
+                  <a:srgbClr val="142824"/>
+                </a:solidFill>
+                <a:latin typeface="Calibri"/>
+              </a:defRPr>
+            </a:pPr>
+            <a:r>
+              <a:rPr>
+                <a:solidFill>
+                  <a:srgbClr val="5EEAD4"/>
+                </a:solidFill>
+              </a:rPr>
+              <a:t>■  GitHub: https://github.com/luisrapalino/concurso-datos-abiertos-colombia-2026</a:t>
+            </a:r>
+          </a:p>
+          <a:p>
+            <a:pPr>
+              <a:spcAft>
+                <a:spcPts val="1000"/>
+              </a:spcAft>
+              <a:defRPr sz="1700">
+                <a:solidFill>
+                  <a:srgbClr val="142824"/>
+                </a:solidFill>
+                <a:latin typeface="Calibri"/>
+              </a:defRPr>
+            </a:pPr>
+            <a:r>
+              <a:rPr>
+                <a:solidFill>
+                  <a:srgbClr val="5EEAD4"/>
+                </a:solidFill>
+              </a:rPr>
+              <a:t>■  README.md — ficha técnica y guía de reproducción</a:t>
+            </a:r>
+          </a:p>
+          <a:p>
+            <a:pPr>
+              <a:spcAft>
+                <a:spcPts val="1000"/>
+              </a:spcAft>
+              <a:defRPr sz="1700">
+                <a:solidFill>
+                  <a:srgbClr val="142824"/>
+                </a:solidFill>
+                <a:latin typeface="Calibri"/>
+              </a:defRPr>
+            </a:pPr>
+            <a:r>
+              <a:rPr>
+                <a:solidFill>
+                  <a:srgbClr val="5EEAD4"/>
+                </a:solidFill>
+              </a:rPr>
+              <a:t>■  docs/concurso-alignment.md — trazabilidad del reto</a:t>
+            </a:r>
+          </a:p>
+          <a:p>
+            <a:pPr>
+              <a:spcAft>
+                <a:spcPts val="1000"/>
+              </a:spcAft>
+              <a:defRPr sz="1700">
+                <a:solidFill>
+                  <a:srgbClr val="142824"/>
+                </a:solidFill>
+                <a:latin typeface="Calibri"/>
+              </a:defRPr>
+            </a:pPr>
+            <a:r>
+              <a:rPr>
+                <a:solidFill>
+                  <a:srgbClr val="5EEAD4"/>
+                </a:solidFill>
+              </a:rPr>
+              <a:t>■  docs/data-dictionary.md — 15 variables del modelo</a:t>
+            </a:r>
+          </a:p>
+          <a:p>
+            <a:pPr>
+              <a:spcAft>
+                <a:spcPts val="1000"/>
+              </a:spcAft>
+              <a:defRPr sz="1700">
+                <a:solidFill>
+                  <a:srgbClr val="142824"/>
+                </a:solidFill>
+                <a:latin typeface="Calibri"/>
+              </a:defRPr>
+            </a:pPr>
+            <a:r>
+              <a:rPr>
+                <a:solidFill>
+                  <a:srgbClr val="5EEAD4"/>
+                </a:solidFill>
+              </a:rPr>
+              <a:t>■  docs/ml-evaluation.md — validación, métricas y límites</a:t>
+            </a:r>
+          </a:p>
+          <a:p>
+            <a:pPr>
+              <a:spcAft>
+                <a:spcPts val="1000"/>
+              </a:spcAft>
+              <a:defRPr sz="1700">
+                <a:solidFill>
+                  <a:srgbClr val="142824"/>
+                </a:solidFill>
+                <a:latin typeface="Calibri"/>
+              </a:defRPr>
+            </a:pPr>
+            <a:r>
+              <a:rPr>
+                <a:solidFill>
+                  <a:srgbClr val="5EEAD4"/>
+                </a:solidFill>
+              </a:rPr>
+              <a:t>■  RECURSOS/ — presentación, PDF y portada</a:t>
+            </a:r>
+          </a:p>
+        </p:txBody>
+      </p:sp>
+      <p:sp>
+        <p:nvSpPr>
+          <p:cNvPr id="7" name="TextBox 6"/>
+          <p:cNvSpPr txBox="1"/>
+          <p:nvPr/>
+        </p:nvSpPr>
+        <p:spPr>
+          <a:xfrm>
+            <a:off x="548640" y="6473952"/>
+            <a:ext cx="8229600" cy="320040"/>
+          </a:xfrm>
+          <a:prstGeom prst="rect">
+            <a:avLst/>
+          </a:prstGeom>
+          <a:noFill/>
+        </p:spPr>
+        <p:txBody>
+          <a:bodyPr wrap="none">
+            <a:spAutoFit/>
+          </a:bodyPr>
+          <a:lstStyle/>
+          <a:p>
+            <a:pPr>
+              <a:defRPr sz="900">
+                <a:solidFill>
+                  <a:srgbClr val="5C6F6B"/>
+                </a:solidFill>
+              </a:defRPr>
+            </a:pPr>
+            <a:r>
+              <a:t>Radar de Brotes · Datos abiertos + IA explicable</a:t>
+            </a:r>
+          </a:p>
+        </p:txBody>
+      </p:sp>
+      <p:sp>
+        <p:nvSpPr>
+          <p:cNvPr id="8" name="TextBox 7"/>
+          <p:cNvSpPr txBox="1"/>
+          <p:nvPr/>
+        </p:nvSpPr>
+        <p:spPr>
+          <a:xfrm>
+            <a:off x="9418320" y="6473952"/>
+            <a:ext cx="2468880" cy="320040"/>
+          </a:xfrm>
+          <a:prstGeom prst="rect">
+            <a:avLst/>
+          </a:prstGeom>
+          <a:noFill/>
+        </p:spPr>
+        <p:txBody>
+          <a:bodyPr wrap="none">
+            <a:spAutoFit/>
+          </a:bodyPr>
+          <a:lstStyle/>
+          <a:p>
+            <a:pPr algn="ctr">
+              <a:defRPr sz="900">
+                <a:solidFill>
+                  <a:srgbClr val="5C6F6B"/>
+                </a:solidFill>
+              </a:defRPr>
+            </a:pPr>
+            <a:r>
+              <a:t>Equipo ID 200</a:t>
+            </a:r>
+          </a:p>
+        </p:txBody>
+      </p:sp>
+    </p:spTree>
+  </p:cSld>
+  <p:clrMapOvr>
+    <a:masterClrMapping/>
+  </p:clrMapOvr>
+</p:sld>
+</file>
+
+<file path=ppt/slides/slide9.xml><?xml version="1.0" encoding="utf-8"?>
 <p:sld xmlns:a="http://schemas.openxmlformats.org/drawingml/2006/main" xmlns:p="http://schemas.openxmlformats.org/presentationml/2006/main" xmlns:r="http://schemas.openxmlformats.org/officeDocument/2006/relationships">
   <p:cSld>
     <p:bg>

</xml_diff>

<commit_message>
chore(concurso): regenerate presentation with RF+SHAP example
Regenerate PPTX/PDF from the updated builder and refresh the pitch outline in RECURSOS/README.

Co-authored-by: Cursor <cursoragent@cursor.com>
</commit_message>
<xml_diff>
--- a/RECURSOS/Presentacion.pptx
+++ b/RECURSOS/Presentacion.pptx
@@ -14,6 +14,7 @@
     <p:sldId id="262" r:id="rId13"/>
     <p:sldId id="263" r:id="rId14"/>
     <p:sldId id="264" r:id="rId15"/>
+    <p:sldId id="265" r:id="rId16"/>
   </p:sldIdLst>
   <p:sldSz cx="12191695" cy="6858000" type="screen4x3"/>
   <p:notesSz cx="6858000" cy="9144000"/>
@@ -3136,6 +3137,192 @@
 </p:sld>
 </file>
 
+<file path=ppt/slides/slide10.xml><?xml version="1.0" encoding="utf-8"?>
+<p:sld xmlns:a="http://schemas.openxmlformats.org/drawingml/2006/main" xmlns:p="http://schemas.openxmlformats.org/presentationml/2006/main" xmlns:r="http://schemas.openxmlformats.org/officeDocument/2006/relationships">
+  <p:cSld>
+    <p:bg>
+      <p:bgPr>
+        <a:solidFill>
+          <a:srgbClr val="F0F5F3"/>
+        </a:solidFill>
+        <a:effectLst/>
+      </p:bgPr>
+    </p:bg>
+    <p:spTree>
+      <p:nvGrpSpPr>
+        <p:cNvPr id="1" name=""/>
+        <p:cNvGrpSpPr/>
+        <p:nvPr/>
+      </p:nvGrpSpPr>
+      <p:grpSpPr/>
+      <p:pic>
+        <p:nvPicPr>
+          <p:cNvPr id="2" name="Picture 1" descr=".bg-closing.png"/>
+          <p:cNvPicPr>
+            <a:picLocks noChangeAspect="1"/>
+          </p:cNvPicPr>
+          <p:nvPr/>
+        </p:nvPicPr>
+        <p:blipFill>
+          <a:blip r:embed="rId2"/>
+          <a:stretch>
+            <a:fillRect/>
+          </a:stretch>
+        </p:blipFill>
+        <p:spPr>
+          <a:xfrm>
+            <a:off x="0" y="0"/>
+            <a:ext cx="12191695" cy="6858000"/>
+          </a:xfrm>
+          <a:prstGeom prst="rect">
+            <a:avLst/>
+          </a:prstGeom>
+        </p:spPr>
+      </p:pic>
+      <p:sp>
+        <p:nvSpPr>
+          <p:cNvPr id="3" name="TextBox 2"/>
+          <p:cNvSpPr txBox="1"/>
+          <p:nvPr/>
+        </p:nvSpPr>
+        <p:spPr>
+          <a:xfrm>
+            <a:off x="822960" y="914400"/>
+            <a:ext cx="8229600" cy="365760"/>
+          </a:xfrm>
+          <a:prstGeom prst="rect">
+            <a:avLst/>
+          </a:prstGeom>
+          <a:noFill/>
+        </p:spPr>
+        <p:txBody>
+          <a:bodyPr wrap="none">
+            <a:spAutoFit/>
+          </a:bodyPr>
+          <a:lstStyle/>
+          <a:p>
+            <a:r>
+              <a:rPr sz="1300" b="1">
+                <a:solidFill>
+                  <a:srgbClr val="5EEAD4"/>
+                </a:solidFill>
+              </a:rPr>
+              <a:t>C I E R R E</a:t>
+            </a:r>
+          </a:p>
+        </p:txBody>
+      </p:sp>
+      <p:sp>
+        <p:nvSpPr>
+          <p:cNvPr id="4" name="TextBox 3"/>
+          <p:cNvSpPr txBox="1"/>
+          <p:nvPr/>
+        </p:nvSpPr>
+        <p:spPr>
+          <a:xfrm>
+            <a:off x="822960" y="1417320"/>
+            <a:ext cx="10241280" cy="1554480"/>
+          </a:xfrm>
+          <a:prstGeom prst="rect">
+            <a:avLst/>
+          </a:prstGeom>
+          <a:noFill/>
+        </p:spPr>
+        <p:txBody>
+          <a:bodyPr wrap="square">
+            <a:spAutoFit/>
+          </a:bodyPr>
+          <a:lstStyle/>
+          <a:p>
+            <a:pPr>
+              <a:defRPr sz="3200" b="1">
+                <a:solidFill>
+                  <a:srgbClr val="FFFFFF"/>
+                </a:solidFill>
+              </a:defRPr>
+            </a:pPr>
+            <a:r>
+              <a:t>Priorizamos municipios con señal de brote usando datos abiertos de Colombia e inteligencia artificial explicable.</a:t>
+            </a:r>
+          </a:p>
+        </p:txBody>
+      </p:sp>
+      <p:sp>
+        <p:nvSpPr>
+          <p:cNvPr id="5" name="TextBox 4"/>
+          <p:cNvSpPr txBox="1"/>
+          <p:nvPr/>
+        </p:nvSpPr>
+        <p:spPr>
+          <a:xfrm>
+            <a:off x="822960" y="3200400"/>
+            <a:ext cx="10058400" cy="2011680"/>
+          </a:xfrm>
+          <a:prstGeom prst="rect">
+            <a:avLst/>
+          </a:prstGeom>
+          <a:noFill/>
+        </p:spPr>
+        <p:txBody>
+          <a:bodyPr wrap="square">
+            <a:spAutoFit/>
+          </a:bodyPr>
+          <a:lstStyle/>
+          <a:p>
+            <a:pPr>
+              <a:spcAft>
+                <a:spcPts val="1200"/>
+              </a:spcAft>
+              <a:defRPr sz="1800">
+                <a:solidFill>
+                  <a:srgbClr val="FFFFFF"/>
+                </a:solidFill>
+              </a:defRPr>
+            </a:pPr>
+            <a:r>
+              <a:t>Integración multifuente · Explicabilidad SHAP · Plataforma demostrable</a:t>
+            </a:r>
+          </a:p>
+          <a:p>
+            <a:pPr>
+              <a:spcAft>
+                <a:spcPts val="1200"/>
+              </a:spcAft>
+              <a:defRPr sz="1600">
+                <a:solidFill>
+                  <a:srgbClr val="FFFFFF"/>
+                </a:solidFill>
+              </a:defRPr>
+            </a:pPr>
+            <a:r>
+              <a:t>https://github.com/luisrapalino/concurso-datos-abiertos-colombia-2026</a:t>
+            </a:r>
+          </a:p>
+          <a:p>
+            <a:pPr>
+              <a:spcAft>
+                <a:spcPts val="1200"/>
+              </a:spcAft>
+              <a:defRPr sz="1600">
+                <a:solidFill>
+                  <a:srgbClr val="5EEAD4"/>
+                </a:solidFill>
+              </a:defRPr>
+            </a:pPr>
+            <a:r>
+              <a:t>Gracias — preguntas técnicas bienvenidas</a:t>
+            </a:r>
+          </a:p>
+        </p:txBody>
+      </p:sp>
+    </p:spTree>
+  </p:cSld>
+  <p:clrMapOvr>
+    <a:masterClrMapping/>
+  </p:clrMapOvr>
+</p:sld>
+</file>
+
 <file path=ppt/slides/slide2.xml><?xml version="1.0" encoding="utf-8"?>
 <p:sld xmlns:a="http://schemas.openxmlformats.org/drawingml/2006/main" xmlns:p="http://schemas.openxmlformats.org/presentationml/2006/main" xmlns:r="http://schemas.openxmlformats.org/officeDocument/2006/relationships">
   <p:cSld>
@@ -5912,7 +6099,7 @@
                   <a:srgbClr val="5EEAD4"/>
                 </a:solidFill>
               </a:rPr>
-              <a:t>EVIDENCIA</a:t>
+              <a:t>IA EXPLICABLE</a:t>
             </a:r>
           </a:p>
         </p:txBody>
@@ -5948,7 +6135,7 @@
               </a:defRPr>
             </a:pPr>
             <a:r>
-              <a:t>Resultados y demo</a:t>
+              <a:t>Random Forest y SHAP — ejemplo básico</a:t>
             </a:r>
           </a:p>
         </p:txBody>
@@ -5996,8 +6183,8 @@
         </p:nvSpPr>
         <p:spPr>
           <a:xfrm>
-            <a:off x="685800" y="1463040"/>
-            <a:ext cx="3383280" cy="1463040"/>
+            <a:off x="548640" y="1417320"/>
+            <a:ext cx="5440680" cy="2148840"/>
           </a:xfrm>
           <a:prstGeom prst="roundRect">
             <a:avLst>
@@ -6044,8 +6231,8 @@
         </p:nvSpPr>
         <p:spPr>
           <a:xfrm>
-            <a:off x="685800" y="1697126"/>
-            <a:ext cx="94731" cy="994867"/>
+            <a:off x="548640" y="1761134"/>
+            <a:ext cx="152339" cy="1461211"/>
           </a:xfrm>
           <a:prstGeom prst="rect">
             <a:avLst/>
@@ -6087,8 +6274,8 @@
         </p:nvSpPr>
         <p:spPr>
           <a:xfrm>
-            <a:off x="1005840" y="1627632"/>
-            <a:ext cx="2834640" cy="822960"/>
+            <a:off x="731520" y="1572768"/>
+            <a:ext cx="5029200" cy="365760"/>
           </a:xfrm>
           <a:prstGeom prst="rect">
             <a:avLst/>
@@ -6102,14 +6289,14 @@
           <a:lstStyle/>
           <a:p>
             <a:pPr>
-              <a:defRPr sz="3600" b="1">
+              <a:defRPr sz="1400" b="1">
                 <a:solidFill>
                   <a:srgbClr val="0A5C54"/>
                 </a:solidFill>
               </a:defRPr>
             </a:pPr>
             <a:r>
-              <a:t>3781</a:t>
+              <a:t>Random Forest</a:t>
             </a:r>
           </a:p>
         </p:txBody>
@@ -6122,8 +6309,8 @@
         </p:nvSpPr>
         <p:spPr>
           <a:xfrm>
-            <a:off x="1005840" y="2395728"/>
-            <a:ext cx="2834640" cy="365760"/>
+            <a:off x="749808" y="1938528"/>
+            <a:ext cx="5029200" cy="1508760"/>
           </a:xfrm>
           <a:prstGeom prst="rect">
             <a:avLst/>
@@ -6131,20 +6318,92 @@
           <a:noFill/>
         </p:spPr>
         <p:txBody>
-          <a:bodyPr wrap="none">
+          <a:bodyPr wrap="square">
             <a:spAutoFit/>
           </a:bodyPr>
           <a:lstStyle/>
           <a:p>
             <a:pPr>
-              <a:defRPr sz="1200">
-                <a:solidFill>
-                  <a:srgbClr val="5C6F6B"/>
-                </a:solidFill>
-              </a:defRPr>
-            </a:pPr>
-            <a:r>
-              <a:t>Muestras ML</a:t>
+              <a:spcAft>
+                <a:spcPts val="1000"/>
+              </a:spcAft>
+              <a:defRPr sz="1100">
+                <a:solidFill>
+                  <a:srgbClr val="142824"/>
+                </a:solidFill>
+                <a:latin typeface="Calibri"/>
+              </a:defRPr>
+            </a:pPr>
+            <a:r>
+              <a:rPr>
+                <a:solidFill>
+                  <a:srgbClr val="5EEAD4"/>
+                </a:solidFill>
+              </a:rPr>
+              <a:t>■  Muchos árboles de decisión entrenados con muestras distintas.</a:t>
+            </a:r>
+          </a:p>
+          <a:p>
+            <a:pPr>
+              <a:spcAft>
+                <a:spcPts val="1000"/>
+              </a:spcAft>
+              <a:defRPr sz="1100">
+                <a:solidFill>
+                  <a:srgbClr val="142824"/>
+                </a:solidFill>
+                <a:latin typeface="Calibri"/>
+              </a:defRPr>
+            </a:pPr>
+            <a:r>
+              <a:rPr>
+                <a:solidFill>
+                  <a:srgbClr val="5EEAD4"/>
+                </a:solidFill>
+              </a:rPr>
+              <a:t>■  Cada árbol responde: ¿señal de brote? (sí / no).</a:t>
+            </a:r>
+          </a:p>
+          <a:p>
+            <a:pPr>
+              <a:spcAft>
+                <a:spcPts val="1000"/>
+              </a:spcAft>
+              <a:defRPr sz="1100">
+                <a:solidFill>
+                  <a:srgbClr val="142824"/>
+                </a:solidFill>
+                <a:latin typeface="Calibri"/>
+              </a:defRPr>
+            </a:pPr>
+            <a:r>
+              <a:rPr>
+                <a:solidFill>
+                  <a:srgbClr val="5EEAD4"/>
+                </a:solidFill>
+              </a:rPr>
+              <a:t>■  La probabilidad final es el promedio de votos del bosque.</a:t>
+            </a:r>
+          </a:p>
+          <a:p>
+            <a:pPr>
+              <a:spcAft>
+                <a:spcPts val="1000"/>
+              </a:spcAft>
+              <a:defRPr sz="1100">
+                <a:solidFill>
+                  <a:srgbClr val="142824"/>
+                </a:solidFill>
+                <a:latin typeface="Calibri"/>
+              </a:defRPr>
+            </a:pPr>
+            <a:r>
+              <a:rPr>
+                <a:solidFill>
+                  <a:srgbClr val="5EEAD4"/>
+                </a:solidFill>
+              </a:rPr>
+              <a:t>■  Robusto ante ruido y combina 15 variables del panel.</a:t>
             </a:r>
           </a:p>
         </p:txBody>
@@ -6157,8 +6416,8 @@
         </p:nvSpPr>
         <p:spPr>
           <a:xfrm>
-            <a:off x="4343400" y="1463040"/>
-            <a:ext cx="3383280" cy="1463040"/>
+            <a:off x="6172200" y="1417320"/>
+            <a:ext cx="5440680" cy="2148840"/>
           </a:xfrm>
           <a:prstGeom prst="roundRect">
             <a:avLst>
@@ -6205,8 +6464,8 @@
         </p:nvSpPr>
         <p:spPr>
           <a:xfrm>
-            <a:off x="4343400" y="1697126"/>
-            <a:ext cx="94731" cy="994867"/>
+            <a:off x="6172200" y="1761134"/>
+            <a:ext cx="152339" cy="1461211"/>
           </a:xfrm>
           <a:prstGeom prst="rect">
             <a:avLst/>
@@ -6248,8 +6507,8 @@
         </p:nvSpPr>
         <p:spPr>
           <a:xfrm>
-            <a:off x="4663440" y="1627632"/>
-            <a:ext cx="2834640" cy="822960"/>
+            <a:off x="6355080" y="1572768"/>
+            <a:ext cx="5029200" cy="365760"/>
           </a:xfrm>
           <a:prstGeom prst="rect">
             <a:avLst/>
@@ -6263,14 +6522,14 @@
           <a:lstStyle/>
           <a:p>
             <a:pPr>
-              <a:defRPr sz="3600" b="1">
-                <a:solidFill>
-                  <a:srgbClr val="B45309"/>
-                </a:solidFill>
-              </a:defRPr>
-            </a:pPr>
-            <a:r>
-              <a:t>2319 / 1462</a:t>
+              <a:defRPr sz="1400" b="1">
+                <a:solidFill>
+                  <a:srgbClr val="0A5C54"/>
+                </a:solidFill>
+              </a:defRPr>
+            </a:pPr>
+            <a:r>
+              <a:t>SHAP (TreeExplainer)</a:t>
             </a:r>
           </a:p>
         </p:txBody>
@@ -6283,8 +6542,8 @@
         </p:nvSpPr>
         <p:spPr>
           <a:xfrm>
-            <a:off x="4663440" y="2395728"/>
-            <a:ext cx="2834640" cy="365760"/>
+            <a:off x="6373368" y="1938528"/>
+            <a:ext cx="5029200" cy="1508760"/>
           </a:xfrm>
           <a:prstGeom prst="rect">
             <a:avLst/>
@@ -6292,20 +6551,92 @@
           <a:noFill/>
         </p:spPr>
         <p:txBody>
-          <a:bodyPr wrap="none">
+          <a:bodyPr wrap="square">
             <a:spAutoFit/>
           </a:bodyPr>
           <a:lstStyle/>
           <a:p>
             <a:pPr>
-              <a:defRPr sz="1200">
-                <a:solidFill>
-                  <a:srgbClr val="5C6F6B"/>
-                </a:solidFill>
-              </a:defRPr>
-            </a:pPr>
-            <a:r>
-              <a:t>Train / Test</a:t>
+              <a:spcAft>
+                <a:spcPts val="1000"/>
+              </a:spcAft>
+              <a:defRPr sz="1100">
+                <a:solidFill>
+                  <a:srgbClr val="142824"/>
+                </a:solidFill>
+                <a:latin typeface="Calibri"/>
+              </a:defRPr>
+            </a:pPr>
+            <a:r>
+              <a:rPr>
+                <a:solidFill>
+                  <a:srgbClr val="5EEAD4"/>
+                </a:solidFill>
+              </a:rPr>
+              <a:t>■  Después de predecir, explica el porqué de la probabilidad.</a:t>
+            </a:r>
+          </a:p>
+          <a:p>
+            <a:pPr>
+              <a:spcAft>
+                <a:spcPts val="1000"/>
+              </a:spcAft>
+              <a:defRPr sz="1100">
+                <a:solidFill>
+                  <a:srgbClr val="142824"/>
+                </a:solidFill>
+                <a:latin typeface="Calibri"/>
+              </a:defRPr>
+            </a:pPr>
+            <a:r>
+              <a:rPr>
+                <a:solidFill>
+                  <a:srgbClr val="5EEAD4"/>
+                </a:solidFill>
+              </a:rPr>
+              <a:t>■  Cada variable recibe una contribución (+ sube, − baja).</a:t>
+            </a:r>
+          </a:p>
+          <a:p>
+            <a:pPr>
+              <a:spcAft>
+                <a:spcPts val="1000"/>
+              </a:spcAft>
+              <a:defRPr sz="1100">
+                <a:solidFill>
+                  <a:srgbClr val="142824"/>
+                </a:solidFill>
+                <a:latin typeface="Calibri"/>
+              </a:defRPr>
+            </a:pPr>
+            <a:r>
+              <a:rPr>
+                <a:solidFill>
+                  <a:srgbClr val="5EEAD4"/>
+                </a:solidFill>
+              </a:rPr>
+              <a:t>■  Las sumas de SHAP reconstruyen la salida del modelo.</a:t>
+            </a:r>
+          </a:p>
+          <a:p>
+            <a:pPr>
+              <a:spcAft>
+                <a:spcPts val="1000"/>
+              </a:spcAft>
+              <a:defRPr sz="1100">
+                <a:solidFill>
+                  <a:srgbClr val="142824"/>
+                </a:solidFill>
+                <a:latin typeface="Calibri"/>
+              </a:defRPr>
+            </a:pPr>
+            <a:r>
+              <a:rPr>
+                <a:solidFill>
+                  <a:srgbClr val="5EEAD4"/>
+                </a:solidFill>
+              </a:rPr>
+              <a:t>■  Misma lógica que en la ficha territorial de la demo.</a:t>
             </a:r>
           </a:p>
         </p:txBody>
@@ -6318,8 +6649,8 @@
         </p:nvSpPr>
         <p:spPr>
           <a:xfrm>
-            <a:off x="8001000" y="1463040"/>
-            <a:ext cx="3383280" cy="1463040"/>
+            <a:off x="548640" y="3794760"/>
+            <a:ext cx="11064240" cy="2331720"/>
           </a:xfrm>
           <a:prstGeom prst="roundRect">
             <a:avLst>
@@ -6366,8 +6697,678 @@
         </p:nvSpPr>
         <p:spPr>
           <a:xfrm>
-            <a:off x="8001000" y="1697126"/>
-            <a:ext cx="94731" cy="994867"/>
+            <a:off x="548640" y="4167835"/>
+            <a:ext cx="309798" cy="1585569"/>
+          </a:xfrm>
+          <a:prstGeom prst="rect">
+            <a:avLst/>
+          </a:prstGeom>
+          <a:solidFill>
+            <a:srgbClr val="5EEAD4"/>
+          </a:solidFill>
+          <a:ln>
+            <a:noFill/>
+          </a:ln>
+        </p:spPr>
+        <p:style>
+          <a:lnRef idx="1">
+            <a:schemeClr val="accent1"/>
+          </a:lnRef>
+          <a:fillRef idx="3">
+            <a:schemeClr val="accent1"/>
+          </a:fillRef>
+          <a:effectRef idx="2">
+            <a:schemeClr val="accent1"/>
+          </a:effectRef>
+          <a:fontRef idx="minor">
+            <a:schemeClr val="lt1"/>
+          </a:fontRef>
+        </p:style>
+        <p:txBody>
+          <a:bodyPr rtlCol="0" anchor="ctr"/>
+          <a:lstStyle/>
+          <a:p>
+            <a:pPr algn="ctr"/>
+          </a:p>
+        </p:txBody>
+      </p:sp>
+      <p:sp>
+        <p:nvSpPr>
+          <p:cNvPr id="16" name="TextBox 15"/>
+          <p:cNvSpPr txBox="1"/>
+          <p:nvPr/>
+        </p:nvSpPr>
+        <p:spPr>
+          <a:xfrm>
+            <a:off x="777240" y="3913632"/>
+            <a:ext cx="10607040" cy="347472"/>
+          </a:xfrm>
+          <a:prstGeom prst="rect">
+            <a:avLst/>
+          </a:prstGeom>
+          <a:noFill/>
+        </p:spPr>
+        <p:txBody>
+          <a:bodyPr wrap="none">
+            <a:spAutoFit/>
+          </a:bodyPr>
+          <a:lstStyle/>
+          <a:p>
+            <a:pPr>
+              <a:defRPr sz="1200" b="1">
+                <a:solidFill>
+                  <a:srgbClr val="0A5C54"/>
+                </a:solidFill>
+              </a:defRPr>
+            </a:pPr>
+            <a:r>
+              <a:t>Ejemplo ilustrativo — municipio con 180 casos dengue, mediana nacional 60, crecimiento semanal ×1.8</a:t>
+            </a:r>
+          </a:p>
+        </p:txBody>
+      </p:sp>
+      <p:sp>
+        <p:nvSpPr>
+          <p:cNvPr id="17" name="TextBox 16"/>
+          <p:cNvSpPr txBox="1"/>
+          <p:nvPr/>
+        </p:nvSpPr>
+        <p:spPr>
+          <a:xfrm>
+            <a:off x="777240" y="4279392"/>
+            <a:ext cx="2926080" cy="502920"/>
+          </a:xfrm>
+          <a:prstGeom prst="rect">
+            <a:avLst/>
+          </a:prstGeom>
+          <a:noFill/>
+        </p:spPr>
+        <p:txBody>
+          <a:bodyPr wrap="none">
+            <a:spAutoFit/>
+          </a:bodyPr>
+          <a:lstStyle/>
+          <a:p>
+            <a:pPr>
+              <a:defRPr sz="1000">
+                <a:solidFill>
+                  <a:srgbClr val="5C6F6B"/>
+                </a:solidFill>
+              </a:defRPr>
+            </a:pPr>
+            <a:r>
+              <a:t>Salida Random Forest</a:t>
+            </a:r>
+          </a:p>
+        </p:txBody>
+      </p:sp>
+      <p:sp>
+        <p:nvSpPr>
+          <p:cNvPr id="18" name="TextBox 17"/>
+          <p:cNvSpPr txBox="1"/>
+          <p:nvPr/>
+        </p:nvSpPr>
+        <p:spPr>
+          <a:xfrm>
+            <a:off x="777240" y="4590288"/>
+            <a:ext cx="2926080" cy="685800"/>
+          </a:xfrm>
+          <a:prstGeom prst="rect">
+            <a:avLst/>
+          </a:prstGeom>
+          <a:noFill/>
+        </p:spPr>
+        <p:txBody>
+          <a:bodyPr wrap="none">
+            <a:spAutoFit/>
+          </a:bodyPr>
+          <a:lstStyle/>
+          <a:p>
+            <a:pPr>
+              <a:defRPr sz="3400" b="1">
+                <a:solidFill>
+                  <a:srgbClr val="B45309"/>
+                </a:solidFill>
+              </a:defRPr>
+            </a:pPr>
+            <a:r>
+              <a:t>82 %</a:t>
+            </a:r>
+          </a:p>
+        </p:txBody>
+      </p:sp>
+      <p:sp>
+        <p:nvSpPr>
+          <p:cNvPr id="19" name="TextBox 18"/>
+          <p:cNvSpPr txBox="1"/>
+          <p:nvPr/>
+        </p:nvSpPr>
+        <p:spPr>
+          <a:xfrm>
+            <a:off x="777240" y="5230368"/>
+            <a:ext cx="2926080" cy="320040"/>
+          </a:xfrm>
+          <a:prstGeom prst="rect">
+            <a:avLst/>
+          </a:prstGeom>
+          <a:noFill/>
+        </p:spPr>
+        <p:txBody>
+          <a:bodyPr wrap="none">
+            <a:spAutoFit/>
+          </a:bodyPr>
+          <a:lstStyle/>
+          <a:p>
+            <a:pPr>
+              <a:defRPr sz="900">
+                <a:solidFill>
+                  <a:srgbClr val="5C6F6B"/>
+                </a:solidFill>
+              </a:defRPr>
+            </a:pPr>
+            <a:r>
+              <a:t>probabilidad de señal de brote</a:t>
+            </a:r>
+          </a:p>
+        </p:txBody>
+      </p:sp>
+      <p:sp>
+        <p:nvSpPr>
+          <p:cNvPr id="20" name="TextBox 19"/>
+          <p:cNvSpPr txBox="1"/>
+          <p:nvPr/>
+        </p:nvSpPr>
+        <p:spPr>
+          <a:xfrm>
+            <a:off x="3977639" y="4315968"/>
+            <a:ext cx="3246120" cy="292608"/>
+          </a:xfrm>
+          <a:prstGeom prst="rect">
+            <a:avLst/>
+          </a:prstGeom>
+          <a:noFill/>
+        </p:spPr>
+        <p:txBody>
+          <a:bodyPr wrap="none">
+            <a:spAutoFit/>
+          </a:bodyPr>
+          <a:lstStyle/>
+          <a:p>
+            <a:pPr>
+              <a:defRPr sz="900">
+                <a:solidFill>
+                  <a:srgbClr val="142824"/>
+                </a:solidFill>
+              </a:defRPr>
+            </a:pPr>
+            <a:r>
+              <a:t>Casos vs mediana nacional</a:t>
+            </a:r>
+          </a:p>
+        </p:txBody>
+      </p:sp>
+      <p:sp>
+        <p:nvSpPr>
+          <p:cNvPr id="21" name="Rectangle 20"/>
+          <p:cNvSpPr/>
+          <p:nvPr/>
+        </p:nvSpPr>
+        <p:spPr>
+          <a:xfrm>
+            <a:off x="7269480" y="4370831"/>
+            <a:ext cx="2710281" cy="164592"/>
+          </a:xfrm>
+          <a:prstGeom prst="rect">
+            <a:avLst/>
+          </a:prstGeom>
+          <a:solidFill>
+            <a:srgbClr val="B45309"/>
+          </a:solidFill>
+          <a:ln>
+            <a:noFill/>
+          </a:ln>
+        </p:spPr>
+        <p:style>
+          <a:lnRef idx="1">
+            <a:schemeClr val="accent1"/>
+          </a:lnRef>
+          <a:fillRef idx="3">
+            <a:schemeClr val="accent1"/>
+          </a:fillRef>
+          <a:effectRef idx="2">
+            <a:schemeClr val="accent1"/>
+          </a:effectRef>
+          <a:fontRef idx="minor">
+            <a:schemeClr val="lt1"/>
+          </a:fontRef>
+        </p:style>
+        <p:txBody>
+          <a:bodyPr rtlCol="0" anchor="ctr"/>
+          <a:lstStyle/>
+          <a:p>
+            <a:pPr algn="ctr"/>
+          </a:p>
+        </p:txBody>
+      </p:sp>
+      <p:sp>
+        <p:nvSpPr>
+          <p:cNvPr id="22" name="TextBox 21"/>
+          <p:cNvSpPr txBox="1"/>
+          <p:nvPr/>
+        </p:nvSpPr>
+        <p:spPr>
+          <a:xfrm>
+            <a:off x="10835640" y="4315968"/>
+            <a:ext cx="640080" cy="292608"/>
+          </a:xfrm>
+          <a:prstGeom prst="rect">
+            <a:avLst/>
+          </a:prstGeom>
+          <a:noFill/>
+        </p:spPr>
+        <p:txBody>
+          <a:bodyPr wrap="none">
+            <a:spAutoFit/>
+          </a:bodyPr>
+          <a:lstStyle/>
+          <a:p>
+            <a:pPr>
+              <a:defRPr sz="1000" b="1">
+                <a:solidFill>
+                  <a:srgbClr val="B45309"/>
+                </a:solidFill>
+              </a:defRPr>
+            </a:pPr>
+            <a:r>
+              <a:t>+28</a:t>
+            </a:r>
+          </a:p>
+        </p:txBody>
+      </p:sp>
+      <p:sp>
+        <p:nvSpPr>
+          <p:cNvPr id="23" name="TextBox 22"/>
+          <p:cNvSpPr txBox="1"/>
+          <p:nvPr/>
+        </p:nvSpPr>
+        <p:spPr>
+          <a:xfrm>
+            <a:off x="3977639" y="4700016"/>
+            <a:ext cx="3246120" cy="292608"/>
+          </a:xfrm>
+          <a:prstGeom prst="rect">
+            <a:avLst/>
+          </a:prstGeom>
+          <a:noFill/>
+        </p:spPr>
+        <p:txBody>
+          <a:bodyPr wrap="none">
+            <a:spAutoFit/>
+          </a:bodyPr>
+          <a:lstStyle/>
+          <a:p>
+            <a:pPr>
+              <a:defRPr sz="900">
+                <a:solidFill>
+                  <a:srgbClr val="142824"/>
+                </a:solidFill>
+              </a:defRPr>
+            </a:pPr>
+            <a:r>
+              <a:t>Crecimiento acelerado (WoW)</a:t>
+            </a:r>
+          </a:p>
+        </p:txBody>
+      </p:sp>
+      <p:sp>
+        <p:nvSpPr>
+          <p:cNvPr id="24" name="Rectangle 23"/>
+          <p:cNvSpPr/>
+          <p:nvPr/>
+        </p:nvSpPr>
+        <p:spPr>
+          <a:xfrm>
+            <a:off x="7269480" y="4754879"/>
+            <a:ext cx="1911095" cy="164592"/>
+          </a:xfrm>
+          <a:prstGeom prst="rect">
+            <a:avLst/>
+          </a:prstGeom>
+          <a:solidFill>
+            <a:srgbClr val="B45309"/>
+          </a:solidFill>
+          <a:ln>
+            <a:noFill/>
+          </a:ln>
+        </p:spPr>
+        <p:style>
+          <a:lnRef idx="1">
+            <a:schemeClr val="accent1"/>
+          </a:lnRef>
+          <a:fillRef idx="3">
+            <a:schemeClr val="accent1"/>
+          </a:fillRef>
+          <a:effectRef idx="2">
+            <a:schemeClr val="accent1"/>
+          </a:effectRef>
+          <a:fontRef idx="minor">
+            <a:schemeClr val="lt1"/>
+          </a:fontRef>
+        </p:style>
+        <p:txBody>
+          <a:bodyPr rtlCol="0" anchor="ctr"/>
+          <a:lstStyle/>
+          <a:p>
+            <a:pPr algn="ctr"/>
+          </a:p>
+        </p:txBody>
+      </p:sp>
+      <p:sp>
+        <p:nvSpPr>
+          <p:cNvPr id="25" name="TextBox 24"/>
+          <p:cNvSpPr txBox="1"/>
+          <p:nvPr/>
+        </p:nvSpPr>
+        <p:spPr>
+          <a:xfrm>
+            <a:off x="10835640" y="4700016"/>
+            <a:ext cx="640080" cy="292608"/>
+          </a:xfrm>
+          <a:prstGeom prst="rect">
+            <a:avLst/>
+          </a:prstGeom>
+          <a:noFill/>
+        </p:spPr>
+        <p:txBody>
+          <a:bodyPr wrap="none">
+            <a:spAutoFit/>
+          </a:bodyPr>
+          <a:lstStyle/>
+          <a:p>
+            <a:pPr>
+              <a:defRPr sz="1000" b="1">
+                <a:solidFill>
+                  <a:srgbClr val="B45309"/>
+                </a:solidFill>
+              </a:defRPr>
+            </a:pPr>
+            <a:r>
+              <a:t>+18</a:t>
+            </a:r>
+          </a:p>
+        </p:txBody>
+      </p:sp>
+      <p:sp>
+        <p:nvSpPr>
+          <p:cNvPr id="26" name="TextBox 25"/>
+          <p:cNvSpPr txBox="1"/>
+          <p:nvPr/>
+        </p:nvSpPr>
+        <p:spPr>
+          <a:xfrm>
+            <a:off x="3977639" y="5084064"/>
+            <a:ext cx="3246120" cy="292608"/>
+          </a:xfrm>
+          <a:prstGeom prst="rect">
+            <a:avLst/>
+          </a:prstGeom>
+          <a:noFill/>
+        </p:spPr>
+        <p:txBody>
+          <a:bodyPr wrap="none">
+            <a:spAutoFit/>
+          </a:bodyPr>
+          <a:lstStyle/>
+          <a:p>
+            <a:pPr>
+              <a:defRPr sz="900">
+                <a:solidFill>
+                  <a:srgbClr val="142824"/>
+                </a:solidFill>
+              </a:defRPr>
+            </a:pPr>
+            <a:r>
+              <a:t>Ratio semana anterior</a:t>
+            </a:r>
+          </a:p>
+        </p:txBody>
+      </p:sp>
+      <p:sp>
+        <p:nvSpPr>
+          <p:cNvPr id="27" name="Rectangle 26"/>
+          <p:cNvSpPr/>
+          <p:nvPr/>
+        </p:nvSpPr>
+        <p:spPr>
+          <a:xfrm>
+            <a:off x="7269480" y="5138927"/>
+            <a:ext cx="1320393" cy="164592"/>
+          </a:xfrm>
+          <a:prstGeom prst="rect">
+            <a:avLst/>
+          </a:prstGeom>
+          <a:solidFill>
+            <a:srgbClr val="B45309"/>
+          </a:solidFill>
+          <a:ln>
+            <a:noFill/>
+          </a:ln>
+        </p:spPr>
+        <p:style>
+          <a:lnRef idx="1">
+            <a:schemeClr val="accent1"/>
+          </a:lnRef>
+          <a:fillRef idx="3">
+            <a:schemeClr val="accent1"/>
+          </a:fillRef>
+          <a:effectRef idx="2">
+            <a:schemeClr val="accent1"/>
+          </a:effectRef>
+          <a:fontRef idx="minor">
+            <a:schemeClr val="lt1"/>
+          </a:fontRef>
+        </p:style>
+        <p:txBody>
+          <a:bodyPr rtlCol="0" anchor="ctr"/>
+          <a:lstStyle/>
+          <a:p>
+            <a:pPr algn="ctr"/>
+          </a:p>
+        </p:txBody>
+      </p:sp>
+      <p:sp>
+        <p:nvSpPr>
+          <p:cNvPr id="28" name="TextBox 27"/>
+          <p:cNvSpPr txBox="1"/>
+          <p:nvPr/>
+        </p:nvSpPr>
+        <p:spPr>
+          <a:xfrm>
+            <a:off x="10835640" y="5084064"/>
+            <a:ext cx="640080" cy="292608"/>
+          </a:xfrm>
+          <a:prstGeom prst="rect">
+            <a:avLst/>
+          </a:prstGeom>
+          <a:noFill/>
+        </p:spPr>
+        <p:txBody>
+          <a:bodyPr wrap="none">
+            <a:spAutoFit/>
+          </a:bodyPr>
+          <a:lstStyle/>
+          <a:p>
+            <a:pPr>
+              <a:defRPr sz="1000" b="1">
+                <a:solidFill>
+                  <a:srgbClr val="B45309"/>
+                </a:solidFill>
+              </a:defRPr>
+            </a:pPr>
+            <a:r>
+              <a:t>+12</a:t>
+            </a:r>
+          </a:p>
+        </p:txBody>
+      </p:sp>
+      <p:sp>
+        <p:nvSpPr>
+          <p:cNvPr id="29" name="TextBox 28"/>
+          <p:cNvSpPr txBox="1"/>
+          <p:nvPr/>
+        </p:nvSpPr>
+        <p:spPr>
+          <a:xfrm>
+            <a:off x="3977639" y="5468112"/>
+            <a:ext cx="3246120" cy="292608"/>
+          </a:xfrm>
+          <a:prstGeom prst="rect">
+            <a:avLst/>
+          </a:prstGeom>
+          <a:noFill/>
+        </p:spPr>
+        <p:txBody>
+          <a:bodyPr wrap="none">
+            <a:spAutoFit/>
+          </a:bodyPr>
+          <a:lstStyle/>
+          <a:p>
+            <a:pPr>
+              <a:defRPr sz="900">
+                <a:solidFill>
+                  <a:srgbClr val="142824"/>
+                </a:solidFill>
+              </a:defRPr>
+            </a:pPr>
+            <a:r>
+              <a:t>Brecha de vacunación</a:t>
+            </a:r>
+          </a:p>
+        </p:txBody>
+      </p:sp>
+      <p:sp>
+        <p:nvSpPr>
+          <p:cNvPr id="30" name="Rectangle 29"/>
+          <p:cNvSpPr/>
+          <p:nvPr/>
+        </p:nvSpPr>
+        <p:spPr>
+          <a:xfrm>
+            <a:off x="7269480" y="5522975"/>
+            <a:ext cx="972921" cy="164592"/>
+          </a:xfrm>
+          <a:prstGeom prst="rect">
+            <a:avLst/>
+          </a:prstGeom>
+          <a:solidFill>
+            <a:srgbClr val="B45309"/>
+          </a:solidFill>
+          <a:ln>
+            <a:noFill/>
+          </a:ln>
+        </p:spPr>
+        <p:style>
+          <a:lnRef idx="1">
+            <a:schemeClr val="accent1"/>
+          </a:lnRef>
+          <a:fillRef idx="3">
+            <a:schemeClr val="accent1"/>
+          </a:fillRef>
+          <a:effectRef idx="2">
+            <a:schemeClr val="accent1"/>
+          </a:effectRef>
+          <a:fontRef idx="minor">
+            <a:schemeClr val="lt1"/>
+          </a:fontRef>
+        </p:style>
+        <p:txBody>
+          <a:bodyPr rtlCol="0" anchor="ctr"/>
+          <a:lstStyle/>
+          <a:p>
+            <a:pPr algn="ctr"/>
+          </a:p>
+        </p:txBody>
+      </p:sp>
+      <p:sp>
+        <p:nvSpPr>
+          <p:cNvPr id="31" name="TextBox 30"/>
+          <p:cNvSpPr txBox="1"/>
+          <p:nvPr/>
+        </p:nvSpPr>
+        <p:spPr>
+          <a:xfrm>
+            <a:off x="10835640" y="5468112"/>
+            <a:ext cx="640080" cy="292608"/>
+          </a:xfrm>
+          <a:prstGeom prst="rect">
+            <a:avLst/>
+          </a:prstGeom>
+          <a:noFill/>
+        </p:spPr>
+        <p:txBody>
+          <a:bodyPr wrap="none">
+            <a:spAutoFit/>
+          </a:bodyPr>
+          <a:lstStyle/>
+          <a:p>
+            <a:pPr>
+              <a:defRPr sz="1000" b="1">
+                <a:solidFill>
+                  <a:srgbClr val="B45309"/>
+                </a:solidFill>
+              </a:defRPr>
+            </a:pPr>
+            <a:r>
+              <a:t>+9</a:t>
+            </a:r>
+          </a:p>
+        </p:txBody>
+      </p:sp>
+      <p:sp>
+        <p:nvSpPr>
+          <p:cNvPr id="32" name="TextBox 31"/>
+          <p:cNvSpPr txBox="1"/>
+          <p:nvPr/>
+        </p:nvSpPr>
+        <p:spPr>
+          <a:xfrm>
+            <a:off x="3977639" y="5852159"/>
+            <a:ext cx="3246120" cy="292608"/>
+          </a:xfrm>
+          <a:prstGeom prst="rect">
+            <a:avLst/>
+          </a:prstGeom>
+          <a:noFill/>
+        </p:spPr>
+        <p:txBody>
+          <a:bodyPr wrap="none">
+            <a:spAutoFit/>
+          </a:bodyPr>
+          <a:lstStyle/>
+          <a:p>
+            <a:pPr>
+              <a:defRPr sz="900">
+                <a:solidFill>
+                  <a:srgbClr val="142824"/>
+                </a:solidFill>
+              </a:defRPr>
+            </a:pPr>
+            <a:r>
+              <a:t>Acceso a salud (partos inst.)</a:t>
+            </a:r>
+          </a:p>
+        </p:txBody>
+      </p:sp>
+      <p:sp>
+        <p:nvSpPr>
+          <p:cNvPr id="33" name="Rectangle 32"/>
+          <p:cNvSpPr/>
+          <p:nvPr/>
+        </p:nvSpPr>
+        <p:spPr>
+          <a:xfrm>
+            <a:off x="7269480" y="5907023"/>
+            <a:ext cx="625449" cy="164592"/>
           </a:xfrm>
           <a:prstGeom prst="rect">
             <a:avLst/>
@@ -6403,14 +7404,14 @@
       </p:sp>
       <p:sp>
         <p:nvSpPr>
-          <p:cNvPr id="16" name="TextBox 15"/>
+          <p:cNvPr id="34" name="TextBox 33"/>
           <p:cNvSpPr txBox="1"/>
           <p:nvPr/>
         </p:nvSpPr>
         <p:spPr>
           <a:xfrm>
-            <a:off x="8321040" y="1627632"/>
-            <a:ext cx="2834640" cy="822960"/>
+            <a:off x="10835640" y="5852159"/>
+            <a:ext cx="640080" cy="292608"/>
           </a:xfrm>
           <a:prstGeom prst="rect">
             <a:avLst/>
@@ -6424,28 +7425,28 @@
           <a:lstStyle/>
           <a:p>
             <a:pPr>
-              <a:defRPr sz="3600" b="1">
+              <a:defRPr sz="1000" b="1">
                 <a:solidFill>
                   <a:srgbClr val="0A5C54"/>
                 </a:solidFill>
               </a:defRPr>
             </a:pPr>
             <a:r>
-              <a:t>1.0</a:t>
-            </a:r>
-          </a:p>
-        </p:txBody>
-      </p:sp>
-      <p:sp>
-        <p:nvSpPr>
-          <p:cNvPr id="17" name="TextBox 16"/>
+              <a:t>−5</a:t>
+            </a:r>
+          </a:p>
+        </p:txBody>
+      </p:sp>
+      <p:sp>
+        <p:nvSpPr>
+          <p:cNvPr id="35" name="TextBox 34"/>
           <p:cNvSpPr txBox="1"/>
           <p:nvPr/>
         </p:nvSpPr>
         <p:spPr>
           <a:xfrm>
-            <a:off x="8321040" y="2395728"/>
-            <a:ext cx="2834640" cy="365760"/>
+            <a:off x="7269480" y="4041648"/>
+            <a:ext cx="4114800" cy="274320"/>
           </a:xfrm>
           <a:prstGeom prst="rect">
             <a:avLst/>
@@ -6459,128 +7460,21 @@
           <a:lstStyle/>
           <a:p>
             <a:pPr>
-              <a:defRPr sz="1200">
+              <a:defRPr sz="1000" b="1">
                 <a:solidFill>
                   <a:srgbClr val="5C6F6B"/>
                 </a:solidFill>
               </a:defRPr>
             </a:pPr>
             <a:r>
-              <a:t>F1 temporal</a:t>
-            </a:r>
-          </a:p>
-        </p:txBody>
-      </p:sp>
-      <p:sp>
-        <p:nvSpPr>
-          <p:cNvPr id="18" name="TextBox 17"/>
-          <p:cNvSpPr txBox="1"/>
-          <p:nvPr/>
-        </p:nvSpPr>
-        <p:spPr>
-          <a:xfrm>
-            <a:off x="822960" y="3246120"/>
-            <a:ext cx="10515600" cy="2743200"/>
-          </a:xfrm>
-          <a:prstGeom prst="rect">
-            <a:avLst/>
-          </a:prstGeom>
-          <a:noFill/>
-        </p:spPr>
-        <p:txBody>
-          <a:bodyPr wrap="square">
-            <a:spAutoFit/>
-          </a:bodyPr>
-          <a:lstStyle/>
-          <a:p>
-            <a:pPr>
-              <a:spcAft>
-                <a:spcPts val="1000"/>
-              </a:spcAft>
-              <a:defRPr sz="1500">
-                <a:solidFill>
-                  <a:srgbClr val="142824"/>
-                </a:solidFill>
-                <a:latin typeface="Calibri"/>
-              </a:defRPr>
-            </a:pPr>
-            <a:r>
-              <a:rPr>
-                <a:solidFill>
-                  <a:srgbClr val="5EEAD4"/>
-                </a:solidFill>
-              </a:rPr>
-              <a:t>■  Modelo promovido: randomforest-outbreak-v1.0.0 (Random Forest + SHAP)</a:t>
-            </a:r>
-          </a:p>
-          <a:p>
-            <a:pPr>
-              <a:spcAft>
-                <a:spcPts val="1000"/>
-              </a:spcAft>
-              <a:defRPr sz="1500">
-                <a:solidFill>
-                  <a:srgbClr val="142824"/>
-                </a:solidFill>
-                <a:latin typeface="Calibri"/>
-              </a:defRPr>
-            </a:pPr>
-            <a:r>
-              <a:rPr>
-                <a:solidFill>
-                  <a:srgbClr val="5EEAD4"/>
-                </a:solidFill>
-              </a:rPr>
-              <a:t>■  Cobertura: 20 ciudades principales · ~9.000 observaciones curadas</a:t>
-            </a:r>
-          </a:p>
-          <a:p>
-            <a:pPr>
-              <a:spcAft>
-                <a:spcPts val="1000"/>
-              </a:spcAft>
-              <a:defRPr sz="1500">
-                <a:solidFill>
-                  <a:srgbClr val="142824"/>
-                </a:solidFill>
-                <a:latin typeface="Calibri"/>
-              </a:defRPr>
-            </a:pPr>
-            <a:r>
-              <a:rPr>
-                <a:solidFill>
-                  <a:srgbClr val="5EEAD4"/>
-                </a:solidFill>
-              </a:rPr>
-              <a:t>■  Cautela: panel acotado; validación epidemiológica externa pendiente</a:t>
-            </a:r>
-          </a:p>
-          <a:p>
-            <a:pPr>
-              <a:spcAft>
-                <a:spcPts val="1000"/>
-              </a:spcAft>
-              <a:defRPr sz="1500">
-                <a:solidFill>
-                  <a:srgbClr val="142824"/>
-                </a:solidFill>
-                <a:latin typeface="Calibri"/>
-              </a:defRPr>
-            </a:pPr>
-            <a:r>
-              <a:rPr>
-                <a:solidFill>
-                  <a:srgbClr val="5EEAD4"/>
-                </a:solidFill>
-              </a:rPr>
-              <a:t>■  Demo en vivo: https://concurso-datos-abiertos-colombia-20.vercel.app/brotes  ·  Mapa /informe  ·  API https://epintel-api.onrender.com/docs</a:t>
-            </a:r>
-          </a:p>
-        </p:txBody>
-      </p:sp>
-      <p:sp>
-        <p:nvSpPr>
-          <p:cNvPr id="19" name="TextBox 18"/>
+              <a:t>Contribuciones SHAP (top 5)</a:t>
+            </a:r>
+          </a:p>
+        </p:txBody>
+      </p:sp>
+      <p:sp>
+        <p:nvSpPr>
+          <p:cNvPr id="36" name="TextBox 35"/>
           <p:cNvSpPr txBox="1"/>
           <p:nvPr/>
         </p:nvSpPr>
@@ -6615,7 +7509,7 @@
       </p:sp>
       <p:sp>
         <p:nvSpPr>
-          <p:cNvPr id="20" name="TextBox 19"/>
+          <p:cNvPr id="37" name="TextBox 36"/>
           <p:cNvSpPr txBox="1"/>
           <p:nvPr/>
         </p:nvSpPr>
@@ -6726,7 +7620,7 @@
                   <a:srgbClr val="5EEAD4"/>
                 </a:solidFill>
               </a:rPr>
-              <a:t>DEMO</a:t>
+              <a:t>EVIDENCIA</a:t>
             </a:r>
           </a:p>
         </p:txBody>
@@ -6762,7 +7656,7 @@
               </a:defRPr>
             </a:pPr>
             <a:r>
-              <a:t>Plataforma en producción</a:t>
+              <a:t>Resultados y demo</a:t>
             </a:r>
           </a:p>
         </p:txBody>
@@ -6810,8 +7704,8 @@
         </p:nvSpPr>
         <p:spPr>
           <a:xfrm>
-            <a:off x="548640" y="1417320"/>
-            <a:ext cx="5440680" cy="4160520"/>
+            <a:off x="685800" y="1463040"/>
+            <a:ext cx="3383280" cy="1463040"/>
           </a:xfrm>
           <a:prstGeom prst="roundRect">
             <a:avLst>
@@ -6858,8 +7752,8 @@
         </p:nvSpPr>
         <p:spPr>
           <a:xfrm>
-            <a:off x="548640" y="2083003"/>
-            <a:ext cx="152339" cy="2829153"/>
+            <a:off x="685800" y="1697126"/>
+            <a:ext cx="94731" cy="994867"/>
           </a:xfrm>
           <a:prstGeom prst="rect">
             <a:avLst/>
@@ -6893,40 +7787,16 @@
           </a:p>
         </p:txBody>
       </p:sp>
-      <p:pic>
-        <p:nvPicPr>
-          <p:cNvPr id="8" name="Picture 7" descr="brotes.png"/>
-          <p:cNvPicPr>
-            <a:picLocks noChangeAspect="1"/>
-          </p:cNvPicPr>
-          <p:nvPr/>
-        </p:nvPicPr>
-        <p:blipFill>
-          <a:blip r:embed="rId3"/>
-          <a:stretch>
-            <a:fillRect/>
-          </a:stretch>
-        </p:blipFill>
-        <p:spPr>
-          <a:xfrm>
-            <a:off x="621792" y="1527048"/>
-            <a:ext cx="5294376" cy="3657600"/>
-          </a:xfrm>
-          <a:prstGeom prst="rect">
-            <a:avLst/>
-          </a:prstGeom>
-        </p:spPr>
-      </p:pic>
-      <p:sp>
-        <p:nvSpPr>
-          <p:cNvPr id="9" name="TextBox 8"/>
+      <p:sp>
+        <p:nvSpPr>
+          <p:cNvPr id="8" name="TextBox 7"/>
           <p:cNvSpPr txBox="1"/>
           <p:nvPr/>
         </p:nvSpPr>
         <p:spPr>
           <a:xfrm>
-            <a:off x="658368" y="5239512"/>
-            <a:ext cx="5221224" cy="320040"/>
+            <a:off x="1005840" y="1627632"/>
+            <a:ext cx="2834640" cy="822960"/>
           </a:xfrm>
           <a:prstGeom prst="rect">
             <a:avLst/>
@@ -6940,14 +7810,49 @@
           <a:lstStyle/>
           <a:p>
             <a:pPr>
-              <a:defRPr sz="1100" b="1">
+              <a:defRPr sz="3600" b="1">
+                <a:solidFill>
+                  <a:srgbClr val="0A5C54"/>
+                </a:solidFill>
+              </a:defRPr>
+            </a:pPr>
+            <a:r>
+              <a:t>3781</a:t>
+            </a:r>
+          </a:p>
+        </p:txBody>
+      </p:sp>
+      <p:sp>
+        <p:nvSpPr>
+          <p:cNvPr id="9" name="TextBox 8"/>
+          <p:cNvSpPr txBox="1"/>
+          <p:nvPr/>
+        </p:nvSpPr>
+        <p:spPr>
+          <a:xfrm>
+            <a:off x="1005840" y="2395728"/>
+            <a:ext cx="2834640" cy="365760"/>
+          </a:xfrm>
+          <a:prstGeom prst="rect">
+            <a:avLst/>
+          </a:prstGeom>
+          <a:noFill/>
+        </p:spPr>
+        <p:txBody>
+          <a:bodyPr wrap="none">
+            <a:spAutoFit/>
+          </a:bodyPr>
+          <a:lstStyle/>
+          <a:p>
+            <a:pPr>
+              <a:defRPr sz="1200">
                 <a:solidFill>
                   <a:srgbClr val="5C6F6B"/>
                 </a:solidFill>
               </a:defRPr>
             </a:pPr>
             <a:r>
-              <a:t>Ficha territorial · señal y explicación SHAP</a:t>
+              <a:t>Muestras ML</a:t>
             </a:r>
           </a:p>
         </p:txBody>
@@ -6960,8 +7865,8 @@
         </p:nvSpPr>
         <p:spPr>
           <a:xfrm>
-            <a:off x="6172200" y="1417320"/>
-            <a:ext cx="5440680" cy="4160520"/>
+            <a:off x="4343400" y="1463040"/>
+            <a:ext cx="3383280" cy="1463040"/>
           </a:xfrm>
           <a:prstGeom prst="roundRect">
             <a:avLst>
@@ -7008,8 +7913,169 @@
         </p:nvSpPr>
         <p:spPr>
           <a:xfrm>
-            <a:off x="6172200" y="2083003"/>
-            <a:ext cx="152339" cy="2829153"/>
+            <a:off x="4343400" y="1697126"/>
+            <a:ext cx="94731" cy="994867"/>
+          </a:xfrm>
+          <a:prstGeom prst="rect">
+            <a:avLst/>
+          </a:prstGeom>
+          <a:solidFill>
+            <a:srgbClr val="B45309"/>
+          </a:solidFill>
+          <a:ln>
+            <a:noFill/>
+          </a:ln>
+        </p:spPr>
+        <p:style>
+          <a:lnRef idx="1">
+            <a:schemeClr val="accent1"/>
+          </a:lnRef>
+          <a:fillRef idx="3">
+            <a:schemeClr val="accent1"/>
+          </a:fillRef>
+          <a:effectRef idx="2">
+            <a:schemeClr val="accent1"/>
+          </a:effectRef>
+          <a:fontRef idx="minor">
+            <a:schemeClr val="lt1"/>
+          </a:fontRef>
+        </p:style>
+        <p:txBody>
+          <a:bodyPr rtlCol="0" anchor="ctr"/>
+          <a:lstStyle/>
+          <a:p>
+            <a:pPr algn="ctr"/>
+          </a:p>
+        </p:txBody>
+      </p:sp>
+      <p:sp>
+        <p:nvSpPr>
+          <p:cNvPr id="12" name="TextBox 11"/>
+          <p:cNvSpPr txBox="1"/>
+          <p:nvPr/>
+        </p:nvSpPr>
+        <p:spPr>
+          <a:xfrm>
+            <a:off x="4663440" y="1627632"/>
+            <a:ext cx="2834640" cy="822960"/>
+          </a:xfrm>
+          <a:prstGeom prst="rect">
+            <a:avLst/>
+          </a:prstGeom>
+          <a:noFill/>
+        </p:spPr>
+        <p:txBody>
+          <a:bodyPr wrap="none">
+            <a:spAutoFit/>
+          </a:bodyPr>
+          <a:lstStyle/>
+          <a:p>
+            <a:pPr>
+              <a:defRPr sz="3600" b="1">
+                <a:solidFill>
+                  <a:srgbClr val="B45309"/>
+                </a:solidFill>
+              </a:defRPr>
+            </a:pPr>
+            <a:r>
+              <a:t>2319 / 1462</a:t>
+            </a:r>
+          </a:p>
+        </p:txBody>
+      </p:sp>
+      <p:sp>
+        <p:nvSpPr>
+          <p:cNvPr id="13" name="TextBox 12"/>
+          <p:cNvSpPr txBox="1"/>
+          <p:nvPr/>
+        </p:nvSpPr>
+        <p:spPr>
+          <a:xfrm>
+            <a:off x="4663440" y="2395728"/>
+            <a:ext cx="2834640" cy="365760"/>
+          </a:xfrm>
+          <a:prstGeom prst="rect">
+            <a:avLst/>
+          </a:prstGeom>
+          <a:noFill/>
+        </p:spPr>
+        <p:txBody>
+          <a:bodyPr wrap="none">
+            <a:spAutoFit/>
+          </a:bodyPr>
+          <a:lstStyle/>
+          <a:p>
+            <a:pPr>
+              <a:defRPr sz="1200">
+                <a:solidFill>
+                  <a:srgbClr val="5C6F6B"/>
+                </a:solidFill>
+              </a:defRPr>
+            </a:pPr>
+            <a:r>
+              <a:t>Train / Test</a:t>
+            </a:r>
+          </a:p>
+        </p:txBody>
+      </p:sp>
+      <p:sp>
+        <p:nvSpPr>
+          <p:cNvPr id="14" name="Rounded Rectangle 13"/>
+          <p:cNvSpPr/>
+          <p:nvPr/>
+        </p:nvSpPr>
+        <p:spPr>
+          <a:xfrm>
+            <a:off x="8001000" y="1463040"/>
+            <a:ext cx="3383280" cy="1463040"/>
+          </a:xfrm>
+          <a:prstGeom prst="roundRect">
+            <a:avLst>
+              <a:gd name="adj" fmla="val 6000"/>
+            </a:avLst>
+          </a:prstGeom>
+          <a:solidFill>
+            <a:srgbClr val="FAFCFB"/>
+          </a:solidFill>
+          <a:ln w="9525">
+            <a:solidFill>
+              <a:srgbClr val="C8D9D4"/>
+            </a:solidFill>
+          </a:ln>
+          <a:effectLst/>
+        </p:spPr>
+        <p:style>
+          <a:lnRef idx="1">
+            <a:schemeClr val="accent1"/>
+          </a:lnRef>
+          <a:fillRef idx="3">
+            <a:schemeClr val="accent1"/>
+          </a:fillRef>
+          <a:effectRef idx="2">
+            <a:schemeClr val="accent1"/>
+          </a:effectRef>
+          <a:fontRef idx="minor">
+            <a:schemeClr val="lt1"/>
+          </a:fontRef>
+        </p:style>
+        <p:txBody>
+          <a:bodyPr rtlCol="0" anchor="ctr"/>
+          <a:lstStyle/>
+          <a:p>
+            <a:pPr algn="ctr"/>
+          </a:p>
+        </p:txBody>
+      </p:sp>
+      <p:sp>
+        <p:nvSpPr>
+          <p:cNvPr id="15" name="Rectangle 14"/>
+          <p:cNvSpPr/>
+          <p:nvPr/>
+        </p:nvSpPr>
+        <p:spPr>
+          <a:xfrm>
+            <a:off x="8001000" y="1697126"/>
+            <a:ext cx="94731" cy="994867"/>
           </a:xfrm>
           <a:prstGeom prst="rect">
             <a:avLst/>
@@ -7043,40 +8109,16 @@
           </a:p>
         </p:txBody>
       </p:sp>
-      <p:pic>
-        <p:nvPicPr>
-          <p:cNvPr id="12" name="Picture 11" descr="mapa.png"/>
-          <p:cNvPicPr>
-            <a:picLocks noChangeAspect="1"/>
-          </p:cNvPicPr>
-          <p:nvPr/>
-        </p:nvPicPr>
-        <p:blipFill>
-          <a:blip r:embed="rId4"/>
-          <a:stretch>
-            <a:fillRect/>
-          </a:stretch>
-        </p:blipFill>
-        <p:spPr>
-          <a:xfrm>
-            <a:off x="6245352" y="1527048"/>
-            <a:ext cx="5294376" cy="3657600"/>
-          </a:xfrm>
-          <a:prstGeom prst="rect">
-            <a:avLst/>
-          </a:prstGeom>
-        </p:spPr>
-      </p:pic>
-      <p:sp>
-        <p:nvSpPr>
-          <p:cNvPr id="13" name="TextBox 12"/>
+      <p:sp>
+        <p:nvSpPr>
+          <p:cNvPr id="16" name="TextBox 15"/>
           <p:cNvSpPr txBox="1"/>
           <p:nvPr/>
         </p:nvSpPr>
         <p:spPr>
           <a:xfrm>
-            <a:off x="6281928" y="5239512"/>
-            <a:ext cx="5221224" cy="320040"/>
+            <a:off x="8321040" y="1627632"/>
+            <a:ext cx="2834640" cy="822960"/>
           </a:xfrm>
           <a:prstGeom prst="rect">
             <a:avLst/>
@@ -7090,28 +8132,28 @@
           <a:lstStyle/>
           <a:p>
             <a:pPr>
-              <a:defRPr sz="1100" b="1">
-                <a:solidFill>
-                  <a:srgbClr val="5C6F6B"/>
-                </a:solidFill>
-              </a:defRPr>
-            </a:pPr>
-            <a:r>
-              <a:t>Mapa de señales · 20 ciudades principales</a:t>
-            </a:r>
-          </a:p>
-        </p:txBody>
-      </p:sp>
-      <p:sp>
-        <p:nvSpPr>
-          <p:cNvPr id="14" name="TextBox 13"/>
+              <a:defRPr sz="3600" b="1">
+                <a:solidFill>
+                  <a:srgbClr val="0A5C54"/>
+                </a:solidFill>
+              </a:defRPr>
+            </a:pPr>
+            <a:r>
+              <a:t>1.0</a:t>
+            </a:r>
+          </a:p>
+        </p:txBody>
+      </p:sp>
+      <p:sp>
+        <p:nvSpPr>
+          <p:cNvPr id="17" name="TextBox 16"/>
           <p:cNvSpPr txBox="1"/>
           <p:nvPr/>
         </p:nvSpPr>
         <p:spPr>
           <a:xfrm>
-            <a:off x="685800" y="5806440"/>
-            <a:ext cx="10789920" cy="411480"/>
+            <a:off x="8321040" y="2395728"/>
+            <a:ext cx="2834640" cy="365760"/>
           </a:xfrm>
           <a:prstGeom prst="rect">
             <a:avLst/>
@@ -7125,21 +8167,128 @@
           <a:lstStyle/>
           <a:p>
             <a:pPr>
-              <a:defRPr sz="1000">
-                <a:solidFill>
-                  <a:srgbClr val="0A5C54"/>
-                </a:solidFill>
-              </a:defRPr>
-            </a:pPr>
-            <a:r>
-              <a:t>https://concurso-datos-abiertos-colombia-20.vercel.app  ·  https://concurso-datos-abiertos-colombia-20.vercel.app/brotes</a:t>
-            </a:r>
-          </a:p>
-        </p:txBody>
-      </p:sp>
-      <p:sp>
-        <p:nvSpPr>
-          <p:cNvPr id="15" name="TextBox 14"/>
+              <a:defRPr sz="1200">
+                <a:solidFill>
+                  <a:srgbClr val="5C6F6B"/>
+                </a:solidFill>
+              </a:defRPr>
+            </a:pPr>
+            <a:r>
+              <a:t>F1 temporal</a:t>
+            </a:r>
+          </a:p>
+        </p:txBody>
+      </p:sp>
+      <p:sp>
+        <p:nvSpPr>
+          <p:cNvPr id="18" name="TextBox 17"/>
+          <p:cNvSpPr txBox="1"/>
+          <p:nvPr/>
+        </p:nvSpPr>
+        <p:spPr>
+          <a:xfrm>
+            <a:off x="822960" y="3246120"/>
+            <a:ext cx="10515600" cy="2743200"/>
+          </a:xfrm>
+          <a:prstGeom prst="rect">
+            <a:avLst/>
+          </a:prstGeom>
+          <a:noFill/>
+        </p:spPr>
+        <p:txBody>
+          <a:bodyPr wrap="square">
+            <a:spAutoFit/>
+          </a:bodyPr>
+          <a:lstStyle/>
+          <a:p>
+            <a:pPr>
+              <a:spcAft>
+                <a:spcPts val="1000"/>
+              </a:spcAft>
+              <a:defRPr sz="1500">
+                <a:solidFill>
+                  <a:srgbClr val="142824"/>
+                </a:solidFill>
+                <a:latin typeface="Calibri"/>
+              </a:defRPr>
+            </a:pPr>
+            <a:r>
+              <a:rPr>
+                <a:solidFill>
+                  <a:srgbClr val="5EEAD4"/>
+                </a:solidFill>
+              </a:rPr>
+              <a:t>■  Modelo promovido: randomforest-outbreak-v1.0.0 (Random Forest + SHAP)</a:t>
+            </a:r>
+          </a:p>
+          <a:p>
+            <a:pPr>
+              <a:spcAft>
+                <a:spcPts val="1000"/>
+              </a:spcAft>
+              <a:defRPr sz="1500">
+                <a:solidFill>
+                  <a:srgbClr val="142824"/>
+                </a:solidFill>
+                <a:latin typeface="Calibri"/>
+              </a:defRPr>
+            </a:pPr>
+            <a:r>
+              <a:rPr>
+                <a:solidFill>
+                  <a:srgbClr val="5EEAD4"/>
+                </a:solidFill>
+              </a:rPr>
+              <a:t>■  Cobertura: 20 ciudades principales · ~9.000 observaciones curadas</a:t>
+            </a:r>
+          </a:p>
+          <a:p>
+            <a:pPr>
+              <a:spcAft>
+                <a:spcPts val="1000"/>
+              </a:spcAft>
+              <a:defRPr sz="1500">
+                <a:solidFill>
+                  <a:srgbClr val="142824"/>
+                </a:solidFill>
+                <a:latin typeface="Calibri"/>
+              </a:defRPr>
+            </a:pPr>
+            <a:r>
+              <a:rPr>
+                <a:solidFill>
+                  <a:srgbClr val="5EEAD4"/>
+                </a:solidFill>
+              </a:rPr>
+              <a:t>■  Cautela: panel acotado; validación epidemiológica externa pendiente</a:t>
+            </a:r>
+          </a:p>
+          <a:p>
+            <a:pPr>
+              <a:spcAft>
+                <a:spcPts val="1000"/>
+              </a:spcAft>
+              <a:defRPr sz="1500">
+                <a:solidFill>
+                  <a:srgbClr val="142824"/>
+                </a:solidFill>
+                <a:latin typeface="Calibri"/>
+              </a:defRPr>
+            </a:pPr>
+            <a:r>
+              <a:rPr>
+                <a:solidFill>
+                  <a:srgbClr val="5EEAD4"/>
+                </a:solidFill>
+              </a:rPr>
+              <a:t>■  Demo en vivo: https://concurso-datos-abiertos-colombia-20.vercel.app/brotes  ·  Mapa /informe  ·  API https://epintel-api.onrender.com/docs</a:t>
+            </a:r>
+          </a:p>
+        </p:txBody>
+      </p:sp>
+      <p:sp>
+        <p:nvSpPr>
+          <p:cNvPr id="19" name="TextBox 18"/>
           <p:cNvSpPr txBox="1"/>
           <p:nvPr/>
         </p:nvSpPr>
@@ -7174,7 +8323,7 @@
       </p:sp>
       <p:sp>
         <p:nvSpPr>
-          <p:cNvPr id="16" name="TextBox 15"/>
+          <p:cNvPr id="20" name="TextBox 19"/>
           <p:cNvSpPr txBox="1"/>
           <p:nvPr/>
         </p:nvSpPr>
@@ -7285,7 +8434,7 @@
                   <a:srgbClr val="5EEAD4"/>
                 </a:solidFill>
               </a:rPr>
-              <a:t>IMPACTO</a:t>
+              <a:t>DEMO</a:t>
             </a:r>
           </a:p>
         </p:txBody>
@@ -7321,7 +8470,7 @@
               </a:defRPr>
             </a:pPr>
             <a:r>
-              <a:t>Impacto y sostenibilidad</a:t>
+              <a:t>Plataforma en producción</a:t>
             </a:r>
           </a:p>
         </p:txBody>
@@ -7369,8 +8518,8 @@
         </p:nvSpPr>
         <p:spPr>
           <a:xfrm>
-            <a:off x="548640" y="1828800"/>
-            <a:ext cx="11064240" cy="822960"/>
+            <a:off x="548640" y="1417320"/>
+            <a:ext cx="5440680" cy="4160520"/>
           </a:xfrm>
           <a:prstGeom prst="roundRect">
             <a:avLst>
@@ -7417,14 +8566,14 @@
         </p:nvSpPr>
         <p:spPr>
           <a:xfrm>
-            <a:off x="548640" y="1960473"/>
-            <a:ext cx="309798" cy="559612"/>
+            <a:off x="548640" y="2083003"/>
+            <a:ext cx="152339" cy="2829153"/>
           </a:xfrm>
           <a:prstGeom prst="rect">
             <a:avLst/>
           </a:prstGeom>
           <a:solidFill>
-            <a:srgbClr val="5EEAD4"/>
+            <a:srgbClr val="0A5C54"/>
           </a:solidFill>
           <a:ln>
             <a:noFill/>
@@ -7452,41 +8601,30 @@
           </a:p>
         </p:txBody>
       </p:sp>
-      <p:sp>
-        <p:nvSpPr>
-          <p:cNvPr id="8" name="TextBox 7"/>
-          <p:cNvSpPr txBox="1"/>
-          <p:nvPr/>
-        </p:nvSpPr>
-        <p:spPr>
-          <a:xfrm>
-            <a:off x="868680" y="1975104"/>
-            <a:ext cx="10424160" cy="640080"/>
-          </a:xfrm>
-          <a:prstGeom prst="rect">
-            <a:avLst/>
-          </a:prstGeom>
-          <a:noFill/>
-        </p:spPr>
-        <p:txBody>
-          <a:bodyPr wrap="square">
-            <a:spAutoFit/>
-          </a:bodyPr>
-          <a:lstStyle/>
-          <a:p>
-            <a:pPr>
-              <a:defRPr sz="1600" b="1">
-                <a:solidFill>
-                  <a:srgbClr val="0A5C54"/>
-                </a:solidFill>
-              </a:defRPr>
-            </a:pPr>
-            <a:r>
-              <a:t>Valor público: prevención y respuesta temprana con trazabilidad</a:t>
-            </a:r>
-          </a:p>
-        </p:txBody>
-      </p:sp>
+      <p:pic>
+        <p:nvPicPr>
+          <p:cNvPr id="8" name="Picture 7" descr="brotes.png"/>
+          <p:cNvPicPr>
+            <a:picLocks noChangeAspect="1"/>
+          </p:cNvPicPr>
+          <p:nvPr/>
+        </p:nvPicPr>
+        <p:blipFill>
+          <a:blip r:embed="rId3"/>
+          <a:stretch>
+            <a:fillRect/>
+          </a:stretch>
+        </p:blipFill>
+        <p:spPr>
+          <a:xfrm>
+            <a:off x="621792" y="1527048"/>
+            <a:ext cx="5294376" cy="3657600"/>
+          </a:xfrm>
+          <a:prstGeom prst="rect">
+            <a:avLst/>
+          </a:prstGeom>
+        </p:spPr>
+      </p:pic>
       <p:sp>
         <p:nvSpPr>
           <p:cNvPr id="9" name="TextBox 8"/>
@@ -7495,136 +8633,8 @@
         </p:nvSpPr>
         <p:spPr>
           <a:xfrm>
-            <a:off x="822960" y="2926080"/>
-            <a:ext cx="10515600" cy="4023360"/>
-          </a:xfrm>
-          <a:prstGeom prst="rect">
-            <a:avLst/>
-          </a:prstGeom>
-          <a:noFill/>
-        </p:spPr>
-        <p:txBody>
-          <a:bodyPr wrap="square">
-            <a:spAutoFit/>
-          </a:bodyPr>
-          <a:lstStyle/>
-          <a:p>
-            <a:pPr>
-              <a:spcAft>
-                <a:spcPts val="1000"/>
-              </a:spcAft>
-              <a:defRPr sz="1700">
-                <a:solidFill>
-                  <a:srgbClr val="142824"/>
-                </a:solidFill>
-                <a:latin typeface="Calibri"/>
-              </a:defRPr>
-            </a:pPr>
-            <a:r>
-              <a:rPr>
-                <a:solidFill>
-                  <a:srgbClr val="5EEAD4"/>
-                </a:solidFill>
-              </a:rPr>
-              <a:t>■  Beneficiarios: equipos de vigilancia en salud pública y gestión territorial</a:t>
-            </a:r>
-          </a:p>
-          <a:p>
-            <a:pPr>
-              <a:spcAft>
-                <a:spcPts val="1000"/>
-              </a:spcAft>
-              <a:defRPr sz="1700">
-                <a:solidFill>
-                  <a:srgbClr val="142824"/>
-                </a:solidFill>
-                <a:latin typeface="Calibri"/>
-              </a:defRPr>
-            </a:pPr>
-            <a:r>
-              <a:rPr>
-                <a:solidFill>
-                  <a:srgbClr val="5EEAD4"/>
-                </a:solidFill>
-              </a:rPr>
-              <a:t>■  Permite focalizar recursos antes del pico de casos</a:t>
-            </a:r>
-          </a:p>
-          <a:p>
-            <a:pPr>
-              <a:spcAft>
-                <a:spcPts val="1000"/>
-              </a:spcAft>
-              <a:defRPr sz="1700">
-                <a:solidFill>
-                  <a:srgbClr val="142824"/>
-                </a:solidFill>
-                <a:latin typeface="Calibri"/>
-              </a:defRPr>
-            </a:pPr>
-            <a:r>
-              <a:rPr>
-                <a:solidFill>
-                  <a:srgbClr val="5EEAD4"/>
-                </a:solidFill>
-              </a:rPr>
-              <a:t>■  Explicación clara de factores — evita caja negra</a:t>
-            </a:r>
-          </a:p>
-          <a:p>
-            <a:pPr>
-              <a:spcAft>
-                <a:spcPts val="1000"/>
-              </a:spcAft>
-              <a:defRPr sz="1700">
-                <a:solidFill>
-                  <a:srgbClr val="142824"/>
-                </a:solidFill>
-                <a:latin typeface="Calibri"/>
-              </a:defRPr>
-            </a:pPr>
-            <a:r>
-              <a:rPr>
-                <a:solidFill>
-                  <a:srgbClr val="5EEAD4"/>
-                </a:solidFill>
-              </a:rPr>
-              <a:t>■  Reproducible con datos abiertos oficiales de Colombia</a:t>
-            </a:r>
-          </a:p>
-          <a:p>
-            <a:pPr>
-              <a:spcAft>
-                <a:spcPts val="1000"/>
-              </a:spcAft>
-              <a:defRPr sz="1700">
-                <a:solidFill>
-                  <a:srgbClr val="142824"/>
-                </a:solidFill>
-                <a:latin typeface="Calibri"/>
-              </a:defRPr>
-            </a:pPr>
-            <a:r>
-              <a:rPr>
-                <a:solidFill>
-                  <a:srgbClr val="5EEAD4"/>
-                </a:solidFill>
-              </a:rPr>
-              <a:t>■  Sostenibilidad: ingestión automática, documentación, CI y despliegue Docker</a:t>
-            </a:r>
-          </a:p>
-        </p:txBody>
-      </p:sp>
-      <p:sp>
-        <p:nvSpPr>
-          <p:cNvPr id="10" name="TextBox 9"/>
-          <p:cNvSpPr txBox="1"/>
-          <p:nvPr/>
-        </p:nvSpPr>
-        <p:spPr>
-          <a:xfrm>
-            <a:off x="548640" y="6473952"/>
-            <a:ext cx="8229600" cy="320040"/>
+            <a:off x="658368" y="5239512"/>
+            <a:ext cx="5221224" cy="320040"/>
           </a:xfrm>
           <a:prstGeom prst="rect">
             <a:avLst/>
@@ -7638,6 +8648,226 @@
           <a:lstStyle/>
           <a:p>
             <a:pPr>
+              <a:defRPr sz="1100" b="1">
+                <a:solidFill>
+                  <a:srgbClr val="5C6F6B"/>
+                </a:solidFill>
+              </a:defRPr>
+            </a:pPr>
+            <a:r>
+              <a:t>Ficha territorial · señal y explicación SHAP</a:t>
+            </a:r>
+          </a:p>
+        </p:txBody>
+      </p:sp>
+      <p:sp>
+        <p:nvSpPr>
+          <p:cNvPr id="10" name="Rounded Rectangle 9"/>
+          <p:cNvSpPr/>
+          <p:nvPr/>
+        </p:nvSpPr>
+        <p:spPr>
+          <a:xfrm>
+            <a:off x="6172200" y="1417320"/>
+            <a:ext cx="5440680" cy="4160520"/>
+          </a:xfrm>
+          <a:prstGeom prst="roundRect">
+            <a:avLst>
+              <a:gd name="adj" fmla="val 6000"/>
+            </a:avLst>
+          </a:prstGeom>
+          <a:solidFill>
+            <a:srgbClr val="FAFCFB"/>
+          </a:solidFill>
+          <a:ln w="9525">
+            <a:solidFill>
+              <a:srgbClr val="C8D9D4"/>
+            </a:solidFill>
+          </a:ln>
+          <a:effectLst/>
+        </p:spPr>
+        <p:style>
+          <a:lnRef idx="1">
+            <a:schemeClr val="accent1"/>
+          </a:lnRef>
+          <a:fillRef idx="3">
+            <a:schemeClr val="accent1"/>
+          </a:fillRef>
+          <a:effectRef idx="2">
+            <a:schemeClr val="accent1"/>
+          </a:effectRef>
+          <a:fontRef idx="minor">
+            <a:schemeClr val="lt1"/>
+          </a:fontRef>
+        </p:style>
+        <p:txBody>
+          <a:bodyPr rtlCol="0" anchor="ctr"/>
+          <a:lstStyle/>
+          <a:p>
+            <a:pPr algn="ctr"/>
+          </a:p>
+        </p:txBody>
+      </p:sp>
+      <p:sp>
+        <p:nvSpPr>
+          <p:cNvPr id="11" name="Rectangle 10"/>
+          <p:cNvSpPr/>
+          <p:nvPr/>
+        </p:nvSpPr>
+        <p:spPr>
+          <a:xfrm>
+            <a:off x="6172200" y="2083003"/>
+            <a:ext cx="152339" cy="2829153"/>
+          </a:xfrm>
+          <a:prstGeom prst="rect">
+            <a:avLst/>
+          </a:prstGeom>
+          <a:solidFill>
+            <a:srgbClr val="0A5C54"/>
+          </a:solidFill>
+          <a:ln>
+            <a:noFill/>
+          </a:ln>
+        </p:spPr>
+        <p:style>
+          <a:lnRef idx="1">
+            <a:schemeClr val="accent1"/>
+          </a:lnRef>
+          <a:fillRef idx="3">
+            <a:schemeClr val="accent1"/>
+          </a:fillRef>
+          <a:effectRef idx="2">
+            <a:schemeClr val="accent1"/>
+          </a:effectRef>
+          <a:fontRef idx="minor">
+            <a:schemeClr val="lt1"/>
+          </a:fontRef>
+        </p:style>
+        <p:txBody>
+          <a:bodyPr rtlCol="0" anchor="ctr"/>
+          <a:lstStyle/>
+          <a:p>
+            <a:pPr algn="ctr"/>
+          </a:p>
+        </p:txBody>
+      </p:sp>
+      <p:pic>
+        <p:nvPicPr>
+          <p:cNvPr id="12" name="Picture 11" descr="mapa.png"/>
+          <p:cNvPicPr>
+            <a:picLocks noChangeAspect="1"/>
+          </p:cNvPicPr>
+          <p:nvPr/>
+        </p:nvPicPr>
+        <p:blipFill>
+          <a:blip r:embed="rId4"/>
+          <a:stretch>
+            <a:fillRect/>
+          </a:stretch>
+        </p:blipFill>
+        <p:spPr>
+          <a:xfrm>
+            <a:off x="6245352" y="1527048"/>
+            <a:ext cx="5294376" cy="3657600"/>
+          </a:xfrm>
+          <a:prstGeom prst="rect">
+            <a:avLst/>
+          </a:prstGeom>
+        </p:spPr>
+      </p:pic>
+      <p:sp>
+        <p:nvSpPr>
+          <p:cNvPr id="13" name="TextBox 12"/>
+          <p:cNvSpPr txBox="1"/>
+          <p:nvPr/>
+        </p:nvSpPr>
+        <p:spPr>
+          <a:xfrm>
+            <a:off x="6281928" y="5239512"/>
+            <a:ext cx="5221224" cy="320040"/>
+          </a:xfrm>
+          <a:prstGeom prst="rect">
+            <a:avLst/>
+          </a:prstGeom>
+          <a:noFill/>
+        </p:spPr>
+        <p:txBody>
+          <a:bodyPr wrap="none">
+            <a:spAutoFit/>
+          </a:bodyPr>
+          <a:lstStyle/>
+          <a:p>
+            <a:pPr>
+              <a:defRPr sz="1100" b="1">
+                <a:solidFill>
+                  <a:srgbClr val="5C6F6B"/>
+                </a:solidFill>
+              </a:defRPr>
+            </a:pPr>
+            <a:r>
+              <a:t>Mapa de señales · 20 ciudades principales</a:t>
+            </a:r>
+          </a:p>
+        </p:txBody>
+      </p:sp>
+      <p:sp>
+        <p:nvSpPr>
+          <p:cNvPr id="14" name="TextBox 13"/>
+          <p:cNvSpPr txBox="1"/>
+          <p:nvPr/>
+        </p:nvSpPr>
+        <p:spPr>
+          <a:xfrm>
+            <a:off x="685800" y="5806440"/>
+            <a:ext cx="10789920" cy="411480"/>
+          </a:xfrm>
+          <a:prstGeom prst="rect">
+            <a:avLst/>
+          </a:prstGeom>
+          <a:noFill/>
+        </p:spPr>
+        <p:txBody>
+          <a:bodyPr wrap="none">
+            <a:spAutoFit/>
+          </a:bodyPr>
+          <a:lstStyle/>
+          <a:p>
+            <a:pPr>
+              <a:defRPr sz="1000">
+                <a:solidFill>
+                  <a:srgbClr val="0A5C54"/>
+                </a:solidFill>
+              </a:defRPr>
+            </a:pPr>
+            <a:r>
+              <a:t>https://concurso-datos-abiertos-colombia-20.vercel.app  ·  https://concurso-datos-abiertos-colombia-20.vercel.app/brotes</a:t>
+            </a:r>
+          </a:p>
+        </p:txBody>
+      </p:sp>
+      <p:sp>
+        <p:nvSpPr>
+          <p:cNvPr id="15" name="TextBox 14"/>
+          <p:cNvSpPr txBox="1"/>
+          <p:nvPr/>
+        </p:nvSpPr>
+        <p:spPr>
+          <a:xfrm>
+            <a:off x="548640" y="6473952"/>
+            <a:ext cx="8229600" cy="320040"/>
+          </a:xfrm>
+          <a:prstGeom prst="rect">
+            <a:avLst/>
+          </a:prstGeom>
+          <a:noFill/>
+        </p:spPr>
+        <p:txBody>
+          <a:bodyPr wrap="none">
+            <a:spAutoFit/>
+          </a:bodyPr>
+          <a:lstStyle/>
+          <a:p>
+            <a:pPr>
               <a:defRPr sz="900">
                 <a:solidFill>
                   <a:srgbClr val="5C6F6B"/>
@@ -7652,7 +8882,7 @@
       </p:sp>
       <p:sp>
         <p:nvSpPr>
-          <p:cNvPr id="11" name="TextBox 10"/>
+          <p:cNvPr id="16" name="TextBox 15"/>
           <p:cNvSpPr txBox="1"/>
           <p:nvPr/>
         </p:nvSpPr>
@@ -7763,7 +8993,7 @@
                   <a:srgbClr val="5EEAD4"/>
                 </a:solidFill>
               </a:rPr>
-              <a:t>ENTREGABLES</a:t>
+              <a:t>IMPACTO</a:t>
             </a:r>
           </a:p>
         </p:txBody>
@@ -7799,7 +9029,7 @@
               </a:defRPr>
             </a:pPr>
             <a:r>
-              <a:t>Repositorio y recursos</a:t>
+              <a:t>Impacto y sostenibilidad</a:t>
             </a:r>
           </a:p>
         </p:txBody>
@@ -7841,13 +9071,139 @@
       </p:sp>
       <p:sp>
         <p:nvSpPr>
-          <p:cNvPr id="6" name="TextBox 5"/>
+          <p:cNvPr id="6" name="Rounded Rectangle 5"/>
+          <p:cNvSpPr/>
+          <p:nvPr/>
+        </p:nvSpPr>
+        <p:spPr>
+          <a:xfrm>
+            <a:off x="548640" y="1828800"/>
+            <a:ext cx="11064240" cy="822960"/>
+          </a:xfrm>
+          <a:prstGeom prst="roundRect">
+            <a:avLst>
+              <a:gd name="adj" fmla="val 6000"/>
+            </a:avLst>
+          </a:prstGeom>
+          <a:solidFill>
+            <a:srgbClr val="FAFCFB"/>
+          </a:solidFill>
+          <a:ln w="9525">
+            <a:solidFill>
+              <a:srgbClr val="C8D9D4"/>
+            </a:solidFill>
+          </a:ln>
+          <a:effectLst/>
+        </p:spPr>
+        <p:style>
+          <a:lnRef idx="1">
+            <a:schemeClr val="accent1"/>
+          </a:lnRef>
+          <a:fillRef idx="3">
+            <a:schemeClr val="accent1"/>
+          </a:fillRef>
+          <a:effectRef idx="2">
+            <a:schemeClr val="accent1"/>
+          </a:effectRef>
+          <a:fontRef idx="minor">
+            <a:schemeClr val="lt1"/>
+          </a:fontRef>
+        </p:style>
+        <p:txBody>
+          <a:bodyPr rtlCol="0" anchor="ctr"/>
+          <a:lstStyle/>
+          <a:p>
+            <a:pPr algn="ctr"/>
+          </a:p>
+        </p:txBody>
+      </p:sp>
+      <p:sp>
+        <p:nvSpPr>
+          <p:cNvPr id="7" name="Rectangle 6"/>
+          <p:cNvSpPr/>
+          <p:nvPr/>
+        </p:nvSpPr>
+        <p:spPr>
+          <a:xfrm>
+            <a:off x="548640" y="1960473"/>
+            <a:ext cx="309798" cy="559612"/>
+          </a:xfrm>
+          <a:prstGeom prst="rect">
+            <a:avLst/>
+          </a:prstGeom>
+          <a:solidFill>
+            <a:srgbClr val="5EEAD4"/>
+          </a:solidFill>
+          <a:ln>
+            <a:noFill/>
+          </a:ln>
+        </p:spPr>
+        <p:style>
+          <a:lnRef idx="1">
+            <a:schemeClr val="accent1"/>
+          </a:lnRef>
+          <a:fillRef idx="3">
+            <a:schemeClr val="accent1"/>
+          </a:fillRef>
+          <a:effectRef idx="2">
+            <a:schemeClr val="accent1"/>
+          </a:effectRef>
+          <a:fontRef idx="minor">
+            <a:schemeClr val="lt1"/>
+          </a:fontRef>
+        </p:style>
+        <p:txBody>
+          <a:bodyPr rtlCol="0" anchor="ctr"/>
+          <a:lstStyle/>
+          <a:p>
+            <a:pPr algn="ctr"/>
+          </a:p>
+        </p:txBody>
+      </p:sp>
+      <p:sp>
+        <p:nvSpPr>
+          <p:cNvPr id="8" name="TextBox 7"/>
           <p:cNvSpPr txBox="1"/>
           <p:nvPr/>
         </p:nvSpPr>
         <p:spPr>
           <a:xfrm>
-            <a:off x="822960" y="1965960"/>
+            <a:off x="868680" y="1975104"/>
+            <a:ext cx="10424160" cy="640080"/>
+          </a:xfrm>
+          <a:prstGeom prst="rect">
+            <a:avLst/>
+          </a:prstGeom>
+          <a:noFill/>
+        </p:spPr>
+        <p:txBody>
+          <a:bodyPr wrap="square">
+            <a:spAutoFit/>
+          </a:bodyPr>
+          <a:lstStyle/>
+          <a:p>
+            <a:pPr>
+              <a:defRPr sz="1600" b="1">
+                <a:solidFill>
+                  <a:srgbClr val="0A5C54"/>
+                </a:solidFill>
+              </a:defRPr>
+            </a:pPr>
+            <a:r>
+              <a:t>Valor público: prevención y respuesta temprana con trazabilidad</a:t>
+            </a:r>
+          </a:p>
+        </p:txBody>
+      </p:sp>
+      <p:sp>
+        <p:nvSpPr>
+          <p:cNvPr id="9" name="TextBox 8"/>
+          <p:cNvSpPr txBox="1"/>
+          <p:nvPr/>
+        </p:nvSpPr>
+        <p:spPr>
+          <a:xfrm>
+            <a:off x="822960" y="2926080"/>
             <a:ext cx="10515600" cy="4023360"/>
           </a:xfrm>
           <a:prstGeom prst="rect">
@@ -7878,7 +9234,7 @@
                   <a:srgbClr val="5EEAD4"/>
                 </a:solidFill>
               </a:rPr>
-              <a:t>■  GitHub: https://github.com/luisrapalino/concurso-datos-abiertos-colombia-2026</a:t>
+              <a:t>■  Beneficiarios: equipos de vigilancia en salud pública y gestión territorial</a:t>
             </a:r>
           </a:p>
           <a:p>
@@ -7899,7 +9255,7 @@
                   <a:srgbClr val="5EEAD4"/>
                 </a:solidFill>
               </a:rPr>
-              <a:t>■  README.md — ficha técnica y guía de reproducción</a:t>
+              <a:t>■  Permite focalizar recursos antes del pico de casos</a:t>
             </a:r>
           </a:p>
           <a:p>
@@ -7920,7 +9276,7 @@
                   <a:srgbClr val="5EEAD4"/>
                 </a:solidFill>
               </a:rPr>
-              <a:t>■  docs/concurso-alignment.md — trazabilidad del reto</a:t>
+              <a:t>■  Explicación clara de factores — evita caja negra</a:t>
             </a:r>
           </a:p>
           <a:p>
@@ -7941,7 +9297,7 @@
                   <a:srgbClr val="5EEAD4"/>
                 </a:solidFill>
               </a:rPr>
-              <a:t>■  docs/data-dictionary.md — 15 variables del modelo</a:t>
+              <a:t>■  Reproducible con datos abiertos oficiales de Colombia</a:t>
             </a:r>
           </a:p>
           <a:p>
@@ -7962,35 +9318,14 @@
                   <a:srgbClr val="5EEAD4"/>
                 </a:solidFill>
               </a:rPr>
-              <a:t>■  docs/ml-evaluation.md — validación, métricas y límites</a:t>
-            </a:r>
-          </a:p>
-          <a:p>
-            <a:pPr>
-              <a:spcAft>
-                <a:spcPts val="1000"/>
-              </a:spcAft>
-              <a:defRPr sz="1700">
-                <a:solidFill>
-                  <a:srgbClr val="142824"/>
-                </a:solidFill>
-                <a:latin typeface="Calibri"/>
-              </a:defRPr>
-            </a:pPr>
-            <a:r>
-              <a:rPr>
-                <a:solidFill>
-                  <a:srgbClr val="5EEAD4"/>
-                </a:solidFill>
-              </a:rPr>
-              <a:t>■  RECURSOS/ — presentación, PDF y portada</a:t>
-            </a:r>
-          </a:p>
-        </p:txBody>
-      </p:sp>
-      <p:sp>
-        <p:nvSpPr>
-          <p:cNvPr id="7" name="TextBox 6"/>
+              <a:t>■  Sostenibilidad: ingestión automática, documentación, CI y despliegue Docker</a:t>
+            </a:r>
+          </a:p>
+        </p:txBody>
+      </p:sp>
+      <p:sp>
+        <p:nvSpPr>
+          <p:cNvPr id="10" name="TextBox 9"/>
           <p:cNvSpPr txBox="1"/>
           <p:nvPr/>
         </p:nvSpPr>
@@ -8025,7 +9360,7 @@
       </p:sp>
       <p:sp>
         <p:nvSpPr>
-          <p:cNvPr id="8" name="TextBox 7"/>
+          <p:cNvPr id="11" name="TextBox 10"/>
           <p:cNvSpPr txBox="1"/>
           <p:nvPr/>
         </p:nvSpPr>
@@ -8086,7 +9421,7 @@
       <p:grpSpPr/>
       <p:pic>
         <p:nvPicPr>
-          <p:cNvPr id="2" name="Picture 1" descr=".bg-closing.png"/>
+          <p:cNvPr id="2" name="Picture 1" descr=".bg-content.png"/>
           <p:cNvPicPr>
             <a:picLocks noChangeAspect="1"/>
           </p:cNvPicPr>
@@ -8116,8 +9451,8 @@
         </p:nvSpPr>
         <p:spPr>
           <a:xfrm>
-            <a:off x="822960" y="914400"/>
-            <a:ext cx="8229600" cy="365760"/>
+            <a:off x="548640" y="146304"/>
+            <a:ext cx="8229600" cy="320040"/>
           </a:xfrm>
           <a:prstGeom prst="rect">
             <a:avLst/>
@@ -8131,12 +9466,12 @@
           <a:lstStyle/>
           <a:p>
             <a:r>
-              <a:rPr sz="1300" b="1">
+              <a:rPr sz="1100" b="1">
                 <a:solidFill>
                   <a:srgbClr val="5EEAD4"/>
                 </a:solidFill>
               </a:rPr>
-              <a:t>C I E R R E</a:t>
+              <a:t>ENTREGABLES</a:t>
             </a:r>
           </a:p>
         </p:txBody>
@@ -8149,8 +9484,79 @@
         </p:nvSpPr>
         <p:spPr>
           <a:xfrm>
-            <a:off x="822960" y="1417320"/>
-            <a:ext cx="10241280" cy="1554480"/>
+            <a:off x="548640" y="457200"/>
+            <a:ext cx="9601200" cy="685800"/>
+          </a:xfrm>
+          <a:prstGeom prst="rect">
+            <a:avLst/>
+          </a:prstGeom>
+          <a:noFill/>
+        </p:spPr>
+        <p:txBody>
+          <a:bodyPr wrap="none">
+            <a:spAutoFit/>
+          </a:bodyPr>
+          <a:lstStyle/>
+          <a:p>
+            <a:pPr>
+              <a:defRPr sz="3000" b="1">
+                <a:solidFill>
+                  <a:srgbClr val="FFFFFF"/>
+                </a:solidFill>
+                <a:latin typeface="Calibri"/>
+              </a:defRPr>
+            </a:pPr>
+            <a:r>
+              <a:t>Repositorio y recursos</a:t>
+            </a:r>
+          </a:p>
+        </p:txBody>
+      </p:sp>
+      <p:sp>
+        <p:nvSpPr>
+          <p:cNvPr id="5" name="TextBox 4"/>
+          <p:cNvSpPr txBox="1"/>
+          <p:nvPr/>
+        </p:nvSpPr>
+        <p:spPr>
+          <a:xfrm>
+            <a:off x="10424160" y="310896"/>
+            <a:ext cx="1463040" cy="548640"/>
+          </a:xfrm>
+          <a:prstGeom prst="rect">
+            <a:avLst/>
+          </a:prstGeom>
+          <a:noFill/>
+        </p:spPr>
+        <p:txBody>
+          <a:bodyPr wrap="none">
+            <a:spAutoFit/>
+          </a:bodyPr>
+          <a:lstStyle/>
+          <a:p>
+            <a:pPr algn="ctr">
+              <a:defRPr sz="2400" b="1">
+                <a:solidFill>
+                  <a:srgbClr val="5EEAD4"/>
+                </a:solidFill>
+              </a:defRPr>
+            </a:pPr>
+            <a:r>
+              <a:t>08</a:t>
+            </a:r>
+          </a:p>
+        </p:txBody>
+      </p:sp>
+      <p:sp>
+        <p:nvSpPr>
+          <p:cNvPr id="6" name="TextBox 5"/>
+          <p:cNvSpPr txBox="1"/>
+          <p:nvPr/>
+        </p:nvSpPr>
+        <p:spPr>
+          <a:xfrm>
+            <a:off x="822960" y="1965960"/>
+            <a:ext cx="10515600" cy="4023360"/>
           </a:xfrm>
           <a:prstGeom prst="rect">
             <a:avLst/>
@@ -8164,28 +9570,142 @@
           <a:lstStyle/>
           <a:p>
             <a:pPr>
-              <a:defRPr sz="3200" b="1">
-                <a:solidFill>
-                  <a:srgbClr val="FFFFFF"/>
-                </a:solidFill>
-              </a:defRPr>
-            </a:pPr>
-            <a:r>
-              <a:t>Priorizamos municipios con señal de brote usando datos abiertos de Colombia e inteligencia artificial explicable.</a:t>
-            </a:r>
-          </a:p>
-        </p:txBody>
-      </p:sp>
-      <p:sp>
-        <p:nvSpPr>
-          <p:cNvPr id="5" name="TextBox 4"/>
+              <a:spcAft>
+                <a:spcPts val="1000"/>
+              </a:spcAft>
+              <a:defRPr sz="1700">
+                <a:solidFill>
+                  <a:srgbClr val="142824"/>
+                </a:solidFill>
+                <a:latin typeface="Calibri"/>
+              </a:defRPr>
+            </a:pPr>
+            <a:r>
+              <a:rPr>
+                <a:solidFill>
+                  <a:srgbClr val="5EEAD4"/>
+                </a:solidFill>
+              </a:rPr>
+              <a:t>■  GitHub: https://github.com/luisrapalino/concurso-datos-abiertos-colombia-2026</a:t>
+            </a:r>
+          </a:p>
+          <a:p>
+            <a:pPr>
+              <a:spcAft>
+                <a:spcPts val="1000"/>
+              </a:spcAft>
+              <a:defRPr sz="1700">
+                <a:solidFill>
+                  <a:srgbClr val="142824"/>
+                </a:solidFill>
+                <a:latin typeface="Calibri"/>
+              </a:defRPr>
+            </a:pPr>
+            <a:r>
+              <a:rPr>
+                <a:solidFill>
+                  <a:srgbClr val="5EEAD4"/>
+                </a:solidFill>
+              </a:rPr>
+              <a:t>■  README.md — ficha técnica y guía de reproducción</a:t>
+            </a:r>
+          </a:p>
+          <a:p>
+            <a:pPr>
+              <a:spcAft>
+                <a:spcPts val="1000"/>
+              </a:spcAft>
+              <a:defRPr sz="1700">
+                <a:solidFill>
+                  <a:srgbClr val="142824"/>
+                </a:solidFill>
+                <a:latin typeface="Calibri"/>
+              </a:defRPr>
+            </a:pPr>
+            <a:r>
+              <a:rPr>
+                <a:solidFill>
+                  <a:srgbClr val="5EEAD4"/>
+                </a:solidFill>
+              </a:rPr>
+              <a:t>■  docs/concurso-alignment.md — trazabilidad del reto</a:t>
+            </a:r>
+          </a:p>
+          <a:p>
+            <a:pPr>
+              <a:spcAft>
+                <a:spcPts val="1000"/>
+              </a:spcAft>
+              <a:defRPr sz="1700">
+                <a:solidFill>
+                  <a:srgbClr val="142824"/>
+                </a:solidFill>
+                <a:latin typeface="Calibri"/>
+              </a:defRPr>
+            </a:pPr>
+            <a:r>
+              <a:rPr>
+                <a:solidFill>
+                  <a:srgbClr val="5EEAD4"/>
+                </a:solidFill>
+              </a:rPr>
+              <a:t>■  docs/data-dictionary.md — 15 variables del modelo</a:t>
+            </a:r>
+          </a:p>
+          <a:p>
+            <a:pPr>
+              <a:spcAft>
+                <a:spcPts val="1000"/>
+              </a:spcAft>
+              <a:defRPr sz="1700">
+                <a:solidFill>
+                  <a:srgbClr val="142824"/>
+                </a:solidFill>
+                <a:latin typeface="Calibri"/>
+              </a:defRPr>
+            </a:pPr>
+            <a:r>
+              <a:rPr>
+                <a:solidFill>
+                  <a:srgbClr val="5EEAD4"/>
+                </a:solidFill>
+              </a:rPr>
+              <a:t>■  docs/ml-evaluation.md — validación, métricas y límites</a:t>
+            </a:r>
+          </a:p>
+          <a:p>
+            <a:pPr>
+              <a:spcAft>
+                <a:spcPts val="1000"/>
+              </a:spcAft>
+              <a:defRPr sz="1700">
+                <a:solidFill>
+                  <a:srgbClr val="142824"/>
+                </a:solidFill>
+                <a:latin typeface="Calibri"/>
+              </a:defRPr>
+            </a:pPr>
+            <a:r>
+              <a:rPr>
+                <a:solidFill>
+                  <a:srgbClr val="5EEAD4"/>
+                </a:solidFill>
+              </a:rPr>
+              <a:t>■  RECURSOS/ — presentación, PDF y portada</a:t>
+            </a:r>
+          </a:p>
+        </p:txBody>
+      </p:sp>
+      <p:sp>
+        <p:nvSpPr>
+          <p:cNvPr id="7" name="TextBox 6"/>
           <p:cNvSpPr txBox="1"/>
           <p:nvPr/>
         </p:nvSpPr>
         <p:spPr>
           <a:xfrm>
-            <a:off x="822960" y="3200400"/>
-            <a:ext cx="10058400" cy="2011680"/>
+            <a:off x="548640" y="6473952"/>
+            <a:ext cx="8229600" cy="320040"/>
           </a:xfrm>
           <a:prstGeom prst="rect">
             <a:avLst/>
@@ -8193,53 +9713,55 @@
           <a:noFill/>
         </p:spPr>
         <p:txBody>
-          <a:bodyPr wrap="square">
+          <a:bodyPr wrap="none">
             <a:spAutoFit/>
           </a:bodyPr>
           <a:lstStyle/>
           <a:p>
             <a:pPr>
-              <a:spcAft>
-                <a:spcPts val="1200"/>
-              </a:spcAft>
-              <a:defRPr sz="1800">
-                <a:solidFill>
-                  <a:srgbClr val="FFFFFF"/>
-                </a:solidFill>
-              </a:defRPr>
-            </a:pPr>
-            <a:r>
-              <a:t>Integración multifuente · Explicabilidad SHAP · Plataforma demostrable</a:t>
-            </a:r>
-          </a:p>
-          <a:p>
-            <a:pPr>
-              <a:spcAft>
-                <a:spcPts val="1200"/>
-              </a:spcAft>
-              <a:defRPr sz="1600">
-                <a:solidFill>
-                  <a:srgbClr val="FFFFFF"/>
-                </a:solidFill>
-              </a:defRPr>
-            </a:pPr>
-            <a:r>
-              <a:t>https://github.com/luisrapalino/concurso-datos-abiertos-colombia-2026</a:t>
-            </a:r>
-          </a:p>
-          <a:p>
-            <a:pPr>
-              <a:spcAft>
-                <a:spcPts val="1200"/>
-              </a:spcAft>
-              <a:defRPr sz="1600">
-                <a:solidFill>
-                  <a:srgbClr val="5EEAD4"/>
-                </a:solidFill>
-              </a:defRPr>
-            </a:pPr>
-            <a:r>
-              <a:t>Gracias — preguntas técnicas bienvenidas</a:t>
+              <a:defRPr sz="900">
+                <a:solidFill>
+                  <a:srgbClr val="5C6F6B"/>
+                </a:solidFill>
+              </a:defRPr>
+            </a:pPr>
+            <a:r>
+              <a:t>Radar de Brotes · Datos abiertos + IA explicable</a:t>
+            </a:r>
+          </a:p>
+        </p:txBody>
+      </p:sp>
+      <p:sp>
+        <p:nvSpPr>
+          <p:cNvPr id="8" name="TextBox 7"/>
+          <p:cNvSpPr txBox="1"/>
+          <p:nvPr/>
+        </p:nvSpPr>
+        <p:spPr>
+          <a:xfrm>
+            <a:off x="9418320" y="6473952"/>
+            <a:ext cx="2468880" cy="320040"/>
+          </a:xfrm>
+          <a:prstGeom prst="rect">
+            <a:avLst/>
+          </a:prstGeom>
+          <a:noFill/>
+        </p:spPr>
+        <p:txBody>
+          <a:bodyPr wrap="none">
+            <a:spAutoFit/>
+          </a:bodyPr>
+          <a:lstStyle/>
+          <a:p>
+            <a:pPr algn="ctr">
+              <a:defRPr sz="900">
+                <a:solidFill>
+                  <a:srgbClr val="5C6F6B"/>
+                </a:solidFill>
+              </a:defRPr>
+            </a:pPr>
+            <a:r>
+              <a:t>Equipo ID 200</a:t>
             </a:r>
           </a:p>
         </p:txBody>

</xml_diff>